<commit_message>
Integrate R4 with current risk analyses
</commit_message>
<xml_diff>
--- a/docs/presentation/TerraPlan.pptx
+++ b/docs/presentation/TerraPlan.pptx
@@ -2,24 +2,24 @@
 <file path=ppt/presentation.xml><?xml version="1.0" encoding="utf-8"?>
 <p:presentation xmlns:p="http://schemas.openxmlformats.org/presentationml/2006/main">
   <p:sldMasterIdLst>
-    <p:sldMasterId xmlns:r="http://schemas.openxmlformats.org/officeDocument/2006/relationships" id="2147483648" r:id="Re91b623b5b0748a3"/>
+    <p:sldMasterId xmlns:r="http://schemas.openxmlformats.org/officeDocument/2006/relationships" id="2147483648" r:id="R2023d563f7ff4921"/>
   </p:sldMasterIdLst>
   <p:notesMasterIdLst>
-    <p:notesMasterId xmlns:r="http://schemas.openxmlformats.org/officeDocument/2006/relationships" r:id="Rc8d12d48acd744f0"/>
+    <p:notesMasterId xmlns:r="http://schemas.openxmlformats.org/officeDocument/2006/relationships" r:id="R21a948751204462d"/>
   </p:notesMasterIdLst>
   <p:sldIdLst>
-    <p:sldId xmlns:r="http://schemas.openxmlformats.org/officeDocument/2006/relationships" id="256" r:id="R5f6a644f1e104766"/>
-    <p:sldId xmlns:r="http://schemas.openxmlformats.org/officeDocument/2006/relationships" id="257" r:id="R11a4713018b14e88"/>
-    <p:sldId xmlns:r="http://schemas.openxmlformats.org/officeDocument/2006/relationships" id="258" r:id="R903bc5912a5d4f8c"/>
-    <p:sldId xmlns:r="http://schemas.openxmlformats.org/officeDocument/2006/relationships" id="259" r:id="R263c223bface44a0"/>
-    <p:sldId xmlns:r="http://schemas.openxmlformats.org/officeDocument/2006/relationships" id="260" r:id="Rb367bb3f809142fd"/>
-    <p:sldId xmlns:r="http://schemas.openxmlformats.org/officeDocument/2006/relationships" id="261" r:id="Rc4c712c5d3ef4eb2"/>
-    <p:sldId xmlns:r="http://schemas.openxmlformats.org/officeDocument/2006/relationships" id="262" r:id="R898165ab4a184e66"/>
-    <p:sldId xmlns:r="http://schemas.openxmlformats.org/officeDocument/2006/relationships" id="263" r:id="R62926076287f4cd0"/>
-    <p:sldId xmlns:r="http://schemas.openxmlformats.org/officeDocument/2006/relationships" id="264" r:id="R8fc920b41d554c79"/>
-    <p:sldId xmlns:r="http://schemas.openxmlformats.org/officeDocument/2006/relationships" id="265" r:id="R28a47d62251146a7"/>
-    <p:sldId xmlns:r="http://schemas.openxmlformats.org/officeDocument/2006/relationships" id="266" r:id="Rf1848150198c4fbe"/>
-    <p:sldId xmlns:r="http://schemas.openxmlformats.org/officeDocument/2006/relationships" id="267" r:id="Rb4ef7266aeff49eb"/>
+    <p:sldId xmlns:r="http://schemas.openxmlformats.org/officeDocument/2006/relationships" id="256" r:id="R15053188c359436b"/>
+    <p:sldId xmlns:r="http://schemas.openxmlformats.org/officeDocument/2006/relationships" id="257" r:id="R44b923eed6144a09"/>
+    <p:sldId xmlns:r="http://schemas.openxmlformats.org/officeDocument/2006/relationships" id="258" r:id="R31f42144eab149de"/>
+    <p:sldId xmlns:r="http://schemas.openxmlformats.org/officeDocument/2006/relationships" id="259" r:id="R493f4c2679214315"/>
+    <p:sldId xmlns:r="http://schemas.openxmlformats.org/officeDocument/2006/relationships" id="260" r:id="R554e14916dfe40cb"/>
+    <p:sldId xmlns:r="http://schemas.openxmlformats.org/officeDocument/2006/relationships" id="261" r:id="Rc32323d9c22e4ac3"/>
+    <p:sldId xmlns:r="http://schemas.openxmlformats.org/officeDocument/2006/relationships" id="262" r:id="R14af91ec1f564223"/>
+    <p:sldId xmlns:r="http://schemas.openxmlformats.org/officeDocument/2006/relationships" id="263" r:id="R8537768d8f3b43f9"/>
+    <p:sldId xmlns:r="http://schemas.openxmlformats.org/officeDocument/2006/relationships" id="264" r:id="R407982ae1d6b4119"/>
+    <p:sldId xmlns:r="http://schemas.openxmlformats.org/officeDocument/2006/relationships" id="265" r:id="R0d5f49da9c0b4fbe"/>
+    <p:sldId xmlns:r="http://schemas.openxmlformats.org/officeDocument/2006/relationships" id="266" r:id="Rb9140e545f684ddb"/>
+    <p:sldId xmlns:r="http://schemas.openxmlformats.org/officeDocument/2006/relationships" id="267" r:id="R3f6c89bbc7314911"/>
   </p:sldIdLst>
   <p:sldSz cx="12192000" cy="6858000"/>
   <p:notesSz cx="6858000" cy="9144000"/>
@@ -1153,7 +1153,7 @@
           <a:lstStyle xmlns:a="http://schemas.openxmlformats.org/drawingml/2006/main"/>
           <a:p xmlns:a="http://schemas.openxmlformats.org/drawingml/2006/main">
             <a:r>
-              <a:t>Источники в репозитории: results/reaction/summary.md; docs/risk_register.md; docs/stakeholders.md; docs/TEAM.md. Все денежные показатели в млн условных единиц, постоянные цены 2035 г. Значения диаграмм округлены до целого, исходные точные значения сохранены в result.json.</a:t>
+              <a:t>Источники в репозитории: results/reaction/summary.md; results/monte_carlo/summary.md; docs/risk_register.md; docs/stakeholders.md. Все денежные показатели в млн условных единиц, постоянные цены 2035 г. Значения диаграмм округлены до целого, исходные точные значения сохранены в result.json.</a:t>
             </a:r>
           </a:p>
         </p:txBody>
@@ -1291,7 +1291,7 @@
   </p:cSld>
   <p:clrMap bg1="lt1" tx1="dk1" bg2="lt2" tx2="dk2" accent1="accent1" accent2="accent2" accent3="accent3" accent4="accent4" accent5="accent5" accent6="accent6" hlink="hlink" folHlink="folHlink"/>
   <p:sldLayoutIdLst>
-    <p:sldLayoutId xmlns:r="http://schemas.openxmlformats.org/officeDocument/2006/relationships" id="2147483649" r:id="R4e4ad1e63b834d84"/>
+    <p:sldLayoutId xmlns:r="http://schemas.openxmlformats.org/officeDocument/2006/relationships" id="2147483649" r:id="R151a49f27fbf493f"/>
   </p:sldLayoutIdLst>
   <p:txStyles>
     <p:titleStyle>
@@ -2442,7 +2442,7 @@
           <p:cNvPr id="6" name="">
             <a:extLst xmlns:a="http://schemas.openxmlformats.org/drawingml/2006/main">
               <a:ext uri="{FF2B5EF4-FFF2-40B4-BE49-F238E27FC236}">
-                <a16:creationId xmlns:a16="http://schemas.microsoft.com/office/drawing/2014/main" id="{30E7D5D2-FD0A-4F9D-9AE4-6A02E2F0D02B}"/>
+                <a16:creationId xmlns:a16="http://schemas.microsoft.com/office/drawing/2014/main" id="{FB2420E1-7802-4DB7-AA14-2B9F90B7C409}"/>
               </a:ext>
             </a:extLst>
           </p:cNvPr>
@@ -2499,7 +2499,7 @@
           <p:cNvPr id="2" name="">
             <a:extLst xmlns:a="http://schemas.openxmlformats.org/drawingml/2006/main">
               <a:ext uri="{FF2B5EF4-FFF2-40B4-BE49-F238E27FC236}">
-                <a16:creationId xmlns:a16="http://schemas.microsoft.com/office/drawing/2014/main" id="{BDC51009-CFCE-4D9F-BF7A-FE38BAABF172}"/>
+                <a16:creationId xmlns:a16="http://schemas.microsoft.com/office/drawing/2014/main" id="{C8E21967-F3D6-43D4-A7C3-97D84B4F7A2E}"/>
               </a:ext>
             </a:extLst>
           </p:cNvPr>
@@ -2556,7 +2556,7 @@
           <p:cNvPr id="3" name="">
             <a:extLst xmlns:a="http://schemas.openxmlformats.org/drawingml/2006/main">
               <a:ext uri="{FF2B5EF4-FFF2-40B4-BE49-F238E27FC236}">
-                <a16:creationId xmlns:a16="http://schemas.microsoft.com/office/drawing/2014/main" id="{56379040-4FE5-4054-8512-ABC5CB76171A}"/>
+                <a16:creationId xmlns:a16="http://schemas.microsoft.com/office/drawing/2014/main" id="{CB308A38-FBE2-4DE5-92C0-9816372DC536}"/>
               </a:ext>
             </a:extLst>
           </p:cNvPr>
@@ -2613,7 +2613,7 @@
           <p:cNvPr id="4" name="">
             <a:extLst xmlns:a="http://schemas.openxmlformats.org/drawingml/2006/main">
               <a:ext uri="{FF2B5EF4-FFF2-40B4-BE49-F238E27FC236}">
-                <a16:creationId xmlns:a16="http://schemas.microsoft.com/office/drawing/2014/main" id="{AC7863D3-B26C-495B-8CBD-7E183E6348FB}"/>
+                <a16:creationId xmlns:a16="http://schemas.microsoft.com/office/drawing/2014/main" id="{F1C13D73-91BC-4714-94C7-7EF2665180AA}"/>
               </a:ext>
             </a:extLst>
           </p:cNvPr>
@@ -2670,7 +2670,7 @@
           <p:cNvPr id="5" name="">
             <a:extLst xmlns:a="http://schemas.openxmlformats.org/drawingml/2006/main">
               <a:ext uri="{FF2B5EF4-FFF2-40B4-BE49-F238E27FC236}">
-                <a16:creationId xmlns:a16="http://schemas.microsoft.com/office/drawing/2014/main" id="{A7B8657A-5C8F-4FB3-ACF4-3DA4E1D76C04}"/>
+                <a16:creationId xmlns:a16="http://schemas.microsoft.com/office/drawing/2014/main" id="{FAA13465-92A1-4DF5-B393-09B4A8E14488}"/>
               </a:ext>
             </a:extLst>
           </p:cNvPr>
@@ -2725,7 +2725,7 @@
     </p:spTree>
     <p:extLst>
       <p:ext uri="{BB962C8B-B14F-4D97-AF65-F5344CB8AC3E}">
-        <p14:creationId xmlns:p14="http://schemas.microsoft.com/office/powerpoint/2010/main" val="392313828"/>
+        <p14:creationId xmlns:p14="http://schemas.microsoft.com/office/powerpoint/2010/main" val="1349779129"/>
       </p:ext>
     </p:extLst>
   </p:cSld>
@@ -2756,7 +2756,7 @@
           <p:cNvPr id="7" name="">
             <a:extLst xmlns:a="http://schemas.openxmlformats.org/drawingml/2006/main">
               <a:ext uri="{FF2B5EF4-FFF2-40B4-BE49-F238E27FC236}">
-                <a16:creationId xmlns:a16="http://schemas.microsoft.com/office/drawing/2014/main" id="{DB66AA56-6A3C-4A9C-AA16-9948342BC812}"/>
+                <a16:creationId xmlns:a16="http://schemas.microsoft.com/office/drawing/2014/main" id="{A7C84B0E-861D-430F-B6C7-5939A67440C5}"/>
               </a:ext>
             </a:extLst>
           </p:cNvPr>
@@ -2813,7 +2813,7 @@
           <p:cNvPr id="2" name="">
             <a:extLst xmlns:a="http://schemas.openxmlformats.org/drawingml/2006/main">
               <a:ext uri="{FF2B5EF4-FFF2-40B4-BE49-F238E27FC236}">
-                <a16:creationId xmlns:a16="http://schemas.microsoft.com/office/drawing/2014/main" id="{4D880245-080A-42FB-925B-E7E933580EF1}"/>
+                <a16:creationId xmlns:a16="http://schemas.microsoft.com/office/drawing/2014/main" id="{900338C0-9E6C-4C15-92A3-1853846F6A0D}"/>
               </a:ext>
             </a:extLst>
           </p:cNvPr>
@@ -2870,7 +2870,7 @@
           <p:cNvPr id="3" name="">
             <a:extLst xmlns:a="http://schemas.openxmlformats.org/drawingml/2006/main">
               <a:ext uri="{FF2B5EF4-FFF2-40B4-BE49-F238E27FC236}">
-                <a16:creationId xmlns:a16="http://schemas.microsoft.com/office/drawing/2014/main" id="{76BB702D-1645-49D9-B497-969114BE5596}"/>
+                <a16:creationId xmlns:a16="http://schemas.microsoft.com/office/drawing/2014/main" id="{251906A3-B168-4C1B-8403-1C4521C0763F}"/>
               </a:ext>
             </a:extLst>
           </p:cNvPr>
@@ -2927,7 +2927,7 @@
           <p:cNvPr id="4" name="">
             <a:extLst xmlns:a="http://schemas.openxmlformats.org/drawingml/2006/main">
               <a:ext uri="{FF2B5EF4-FFF2-40B4-BE49-F238E27FC236}">
-                <a16:creationId xmlns:a16="http://schemas.microsoft.com/office/drawing/2014/main" id="{A862F967-F8A8-4E92-B728-BFF31B32E40E}"/>
+                <a16:creationId xmlns:a16="http://schemas.microsoft.com/office/drawing/2014/main" id="{D4F01562-25C8-45BB-8913-E7874FF2E845}"/>
               </a:ext>
             </a:extLst>
           </p:cNvPr>
@@ -2984,7 +2984,7 @@
           <p:cNvPr id="5" name="">
             <a:extLst xmlns:a="http://schemas.openxmlformats.org/drawingml/2006/main">
               <a:ext uri="{FF2B5EF4-FFF2-40B4-BE49-F238E27FC236}">
-                <a16:creationId xmlns:a16="http://schemas.microsoft.com/office/drawing/2014/main" id="{DB5FD32D-09C0-4635-BD99-0FD094A8CAAB}"/>
+                <a16:creationId xmlns:a16="http://schemas.microsoft.com/office/drawing/2014/main" id="{693EB69D-F173-46C8-A9EB-0D426B9CFF4B}"/>
               </a:ext>
             </a:extLst>
           </p:cNvPr>
@@ -3041,7 +3041,7 @@
           <p:cNvPr id="6" name="">
             <a:extLst xmlns:a="http://schemas.openxmlformats.org/drawingml/2006/main">
               <a:ext uri="{FF2B5EF4-FFF2-40B4-BE49-F238E27FC236}">
-                <a16:creationId xmlns:a16="http://schemas.microsoft.com/office/drawing/2014/main" id="{C939D1B8-B935-4837-B7AF-0E36D85D8C26}"/>
+                <a16:creationId xmlns:a16="http://schemas.microsoft.com/office/drawing/2014/main" id="{2D3D45D4-8DD8-483D-81A2-B33BAEEF6DB6}"/>
               </a:ext>
             </a:extLst>
           </p:cNvPr>
@@ -3096,7 +3096,7 @@
     </p:spTree>
     <p:extLst>
       <p:ext uri="{BB962C8B-B14F-4D97-AF65-F5344CB8AC3E}">
-        <p14:creationId xmlns:p14="http://schemas.microsoft.com/office/powerpoint/2010/main" val="152508047"/>
+        <p14:creationId xmlns:p14="http://schemas.microsoft.com/office/powerpoint/2010/main" val="60625322"/>
       </p:ext>
     </p:extLst>
   </p:cSld>
@@ -3127,7 +3127,7 @@
           <p:cNvPr id="5" name="">
             <a:extLst xmlns:a="http://schemas.openxmlformats.org/drawingml/2006/main">
               <a:ext uri="{FF2B5EF4-FFF2-40B4-BE49-F238E27FC236}">
-                <a16:creationId xmlns:a16="http://schemas.microsoft.com/office/drawing/2014/main" id="{6293DD76-FA41-4C82-8F6C-E104BC66BFFF}"/>
+                <a16:creationId xmlns:a16="http://schemas.microsoft.com/office/drawing/2014/main" id="{D2F8DD99-F793-406B-902F-61E00406707D}"/>
               </a:ext>
             </a:extLst>
           </p:cNvPr>
@@ -3191,7 +3191,7 @@
         </p:xfrm>
         <a:graphic xmlns:a="http://schemas.openxmlformats.org/drawingml/2006/main">
           <a:graphicData uri="http://schemas.openxmlformats.org/drawingml/2006/chart">
-            <c:chart xmlns:r="http://schemas.openxmlformats.org/officeDocument/2006/relationships" xmlns:c="http://schemas.openxmlformats.org/drawingml/2006/chart" r:id="Ref51d40e1403460b"/>
+            <c:chart xmlns:r="http://schemas.openxmlformats.org/officeDocument/2006/relationships" xmlns:c="http://schemas.openxmlformats.org/drawingml/2006/chart" r:id="Rc8d82aaa69d64505"/>
           </a:graphicData>
         </a:graphic>
       </p:graphicFrame>
@@ -3200,7 +3200,7 @@
           <p:cNvPr id="3" name="">
             <a:extLst xmlns:a="http://schemas.openxmlformats.org/drawingml/2006/main">
               <a:ext uri="{FF2B5EF4-FFF2-40B4-BE49-F238E27FC236}">
-                <a16:creationId xmlns:a16="http://schemas.microsoft.com/office/drawing/2014/main" id="{30AAA2F0-7261-44B4-A688-0E7AD42C87F1}"/>
+                <a16:creationId xmlns:a16="http://schemas.microsoft.com/office/drawing/2014/main" id="{C0B456B2-B63B-4D28-A45E-4F53BCE91EDC}"/>
               </a:ext>
             </a:extLst>
           </p:cNvPr>
@@ -3257,7 +3257,7 @@
           <p:cNvPr id="4" name="">
             <a:extLst xmlns:a="http://schemas.openxmlformats.org/drawingml/2006/main">
               <a:ext uri="{FF2B5EF4-FFF2-40B4-BE49-F238E27FC236}">
-                <a16:creationId xmlns:a16="http://schemas.microsoft.com/office/drawing/2014/main" id="{A9FDC68A-AA80-4DE7-8F5E-E61B86C995B3}"/>
+                <a16:creationId xmlns:a16="http://schemas.microsoft.com/office/drawing/2014/main" id="{17BB639C-68C0-4648-A537-8F6800B3093E}"/>
               </a:ext>
             </a:extLst>
           </p:cNvPr>
@@ -3312,7 +3312,7 @@
     </p:spTree>
     <p:extLst>
       <p:ext uri="{BB962C8B-B14F-4D97-AF65-F5344CB8AC3E}">
-        <p14:creationId xmlns:p14="http://schemas.microsoft.com/office/powerpoint/2010/main" val="2017769981"/>
+        <p14:creationId xmlns:p14="http://schemas.microsoft.com/office/powerpoint/2010/main" val="849464254"/>
       </p:ext>
     </p:extLst>
   </p:cSld>
@@ -3343,7 +3343,7 @@
           <p:cNvPr id="8" name="">
             <a:extLst xmlns:a="http://schemas.openxmlformats.org/drawingml/2006/main">
               <a:ext uri="{FF2B5EF4-FFF2-40B4-BE49-F238E27FC236}">
-                <a16:creationId xmlns:a16="http://schemas.microsoft.com/office/drawing/2014/main" id="{905EDFDB-2CD6-4209-8F9B-81D83D00D665}"/>
+                <a16:creationId xmlns:a16="http://schemas.microsoft.com/office/drawing/2014/main" id="{47B4E163-52E2-4376-9638-78856E5B1C67}"/>
               </a:ext>
             </a:extLst>
           </p:cNvPr>
@@ -3400,7 +3400,7 @@
           <p:cNvPr id="2" name="">
             <a:extLst xmlns:a="http://schemas.openxmlformats.org/drawingml/2006/main">
               <a:ext uri="{FF2B5EF4-FFF2-40B4-BE49-F238E27FC236}">
-                <a16:creationId xmlns:a16="http://schemas.microsoft.com/office/drawing/2014/main" id="{C01C5382-1B66-4EE1-BC02-F0FE86A7602E}"/>
+                <a16:creationId xmlns:a16="http://schemas.microsoft.com/office/drawing/2014/main" id="{9D9CF54E-9110-4181-9D9B-4F99CAEDA10C}"/>
               </a:ext>
             </a:extLst>
           </p:cNvPr>
@@ -3457,7 +3457,7 @@
           <p:cNvPr id="3" name="">
             <a:extLst xmlns:a="http://schemas.openxmlformats.org/drawingml/2006/main">
               <a:ext uri="{FF2B5EF4-FFF2-40B4-BE49-F238E27FC236}">
-                <a16:creationId xmlns:a16="http://schemas.microsoft.com/office/drawing/2014/main" id="{1EE67958-55A7-4580-8ABC-D7D39D7D7652}"/>
+                <a16:creationId xmlns:a16="http://schemas.microsoft.com/office/drawing/2014/main" id="{0C784DF3-411E-430C-82AA-5348A22A320C}"/>
               </a:ext>
             </a:extLst>
           </p:cNvPr>
@@ -3514,7 +3514,7 @@
           <p:cNvPr id="4" name="">
             <a:extLst xmlns:a="http://schemas.openxmlformats.org/drawingml/2006/main">
               <a:ext uri="{FF2B5EF4-FFF2-40B4-BE49-F238E27FC236}">
-                <a16:creationId xmlns:a16="http://schemas.microsoft.com/office/drawing/2014/main" id="{9E533A83-DF8C-476F-BC66-133FF95596F2}"/>
+                <a16:creationId xmlns:a16="http://schemas.microsoft.com/office/drawing/2014/main" id="{CBCE5DDF-68FA-4FB3-9A63-E2E14A661A2E}"/>
               </a:ext>
             </a:extLst>
           </p:cNvPr>
@@ -3571,7 +3571,7 @@
           <p:cNvPr id="5" name="">
             <a:extLst xmlns:a="http://schemas.openxmlformats.org/drawingml/2006/main">
               <a:ext uri="{FF2B5EF4-FFF2-40B4-BE49-F238E27FC236}">
-                <a16:creationId xmlns:a16="http://schemas.microsoft.com/office/drawing/2014/main" id="{F07D6004-7416-4832-BF44-FA496BE8B0E8}"/>
+                <a16:creationId xmlns:a16="http://schemas.microsoft.com/office/drawing/2014/main" id="{A078B0F3-C0D1-469C-885C-5B03DED258E4}"/>
               </a:ext>
             </a:extLst>
           </p:cNvPr>
@@ -3628,7 +3628,7 @@
           <p:cNvPr id="6" name="">
             <a:extLst xmlns:a="http://schemas.openxmlformats.org/drawingml/2006/main">
               <a:ext uri="{FF2B5EF4-FFF2-40B4-BE49-F238E27FC236}">
-                <a16:creationId xmlns:a16="http://schemas.microsoft.com/office/drawing/2014/main" id="{B2D8EF5A-58BE-43E8-AED9-27862039BA65}"/>
+                <a16:creationId xmlns:a16="http://schemas.microsoft.com/office/drawing/2014/main" id="{4FC50294-7290-4A3A-838C-A0E0630C9D48}"/>
               </a:ext>
             </a:extLst>
           </p:cNvPr>
@@ -3685,7 +3685,7 @@
           <p:cNvPr id="7" name="">
             <a:extLst xmlns:a="http://schemas.openxmlformats.org/drawingml/2006/main">
               <a:ext uri="{FF2B5EF4-FFF2-40B4-BE49-F238E27FC236}">
-                <a16:creationId xmlns:a16="http://schemas.microsoft.com/office/drawing/2014/main" id="{549C2CCB-6030-4273-BC3A-983F28E66626}"/>
+                <a16:creationId xmlns:a16="http://schemas.microsoft.com/office/drawing/2014/main" id="{A2D20ABD-223F-4914-92B7-A9F63DD3A6D6}"/>
               </a:ext>
             </a:extLst>
           </p:cNvPr>
@@ -3740,7 +3740,7 @@
     </p:spTree>
     <p:extLst>
       <p:ext uri="{BB962C8B-B14F-4D97-AF65-F5344CB8AC3E}">
-        <p14:creationId xmlns:p14="http://schemas.microsoft.com/office/powerpoint/2010/main" val="1677103140"/>
+        <p14:creationId xmlns:p14="http://schemas.microsoft.com/office/powerpoint/2010/main" val="416037459"/>
       </p:ext>
     </p:extLst>
   </p:cSld>
@@ -3771,7 +3771,7 @@
           <p:cNvPr id="7" name="">
             <a:extLst xmlns:a="http://schemas.openxmlformats.org/drawingml/2006/main">
               <a:ext uri="{FF2B5EF4-FFF2-40B4-BE49-F238E27FC236}">
-                <a16:creationId xmlns:a16="http://schemas.microsoft.com/office/drawing/2014/main" id="{17D0EAB4-819B-42FC-ABA4-5314ACCC5D8D}"/>
+                <a16:creationId xmlns:a16="http://schemas.microsoft.com/office/drawing/2014/main" id="{01F24C35-4834-40FF-8972-396853B35F11}"/>
               </a:ext>
             </a:extLst>
           </p:cNvPr>
@@ -3828,7 +3828,7 @@
           <p:cNvPr id="2" name="">
             <a:extLst xmlns:a="http://schemas.openxmlformats.org/drawingml/2006/main">
               <a:ext uri="{FF2B5EF4-FFF2-40B4-BE49-F238E27FC236}">
-                <a16:creationId xmlns:a16="http://schemas.microsoft.com/office/drawing/2014/main" id="{2726D15B-562F-4C1F-B6B1-8E29CD9BEBE6}"/>
+                <a16:creationId xmlns:a16="http://schemas.microsoft.com/office/drawing/2014/main" id="{95D5A675-7425-4767-9DB5-72F238C9020C}"/>
               </a:ext>
             </a:extLst>
           </p:cNvPr>
@@ -3885,7 +3885,7 @@
           <p:cNvPr id="3" name="">
             <a:extLst xmlns:a="http://schemas.openxmlformats.org/drawingml/2006/main">
               <a:ext uri="{FF2B5EF4-FFF2-40B4-BE49-F238E27FC236}">
-                <a16:creationId xmlns:a16="http://schemas.microsoft.com/office/drawing/2014/main" id="{5A641D0B-6488-4B09-B3AC-D1F68940439F}"/>
+                <a16:creationId xmlns:a16="http://schemas.microsoft.com/office/drawing/2014/main" id="{802D75F2-9ECF-4E21-9CE1-C97ABC7C12B8}"/>
               </a:ext>
             </a:extLst>
           </p:cNvPr>
@@ -3942,7 +3942,7 @@
           <p:cNvPr id="4" name="">
             <a:extLst xmlns:a="http://schemas.openxmlformats.org/drawingml/2006/main">
               <a:ext uri="{FF2B5EF4-FFF2-40B4-BE49-F238E27FC236}">
-                <a16:creationId xmlns:a16="http://schemas.microsoft.com/office/drawing/2014/main" id="{1FCAAFD9-4E1F-4EBB-AD36-489383E2EDE1}"/>
+                <a16:creationId xmlns:a16="http://schemas.microsoft.com/office/drawing/2014/main" id="{CD3D19EF-1B8A-45B8-B0CD-8C64D99FB797}"/>
               </a:ext>
             </a:extLst>
           </p:cNvPr>
@@ -3999,7 +3999,7 @@
           <p:cNvPr id="5" name="">
             <a:extLst xmlns:a="http://schemas.openxmlformats.org/drawingml/2006/main">
               <a:ext uri="{FF2B5EF4-FFF2-40B4-BE49-F238E27FC236}">
-                <a16:creationId xmlns:a16="http://schemas.microsoft.com/office/drawing/2014/main" id="{340CCF1D-7AF9-41E5-9786-4E4917A30D1E}"/>
+                <a16:creationId xmlns:a16="http://schemas.microsoft.com/office/drawing/2014/main" id="{826E69A1-A199-4213-BD10-FA93DE3DBA29}"/>
               </a:ext>
             </a:extLst>
           </p:cNvPr>
@@ -4056,7 +4056,7 @@
           <p:cNvPr id="6" name="">
             <a:extLst xmlns:a="http://schemas.openxmlformats.org/drawingml/2006/main">
               <a:ext uri="{FF2B5EF4-FFF2-40B4-BE49-F238E27FC236}">
-                <a16:creationId xmlns:a16="http://schemas.microsoft.com/office/drawing/2014/main" id="{6544252A-0C46-4BE9-87FD-EAD89F45DEEF}"/>
+                <a16:creationId xmlns:a16="http://schemas.microsoft.com/office/drawing/2014/main" id="{B305FB6D-FC27-4C88-904F-B58EC338F5DA}"/>
               </a:ext>
             </a:extLst>
           </p:cNvPr>
@@ -4111,7 +4111,7 @@
     </p:spTree>
     <p:extLst>
       <p:ext uri="{BB962C8B-B14F-4D97-AF65-F5344CB8AC3E}">
-        <p14:creationId xmlns:p14="http://schemas.microsoft.com/office/powerpoint/2010/main" val="917172783"/>
+        <p14:creationId xmlns:p14="http://schemas.microsoft.com/office/powerpoint/2010/main" val="428898923"/>
       </p:ext>
     </p:extLst>
   </p:cSld>
@@ -4142,7 +4142,7 @@
           <p:cNvPr id="7" name="">
             <a:extLst xmlns:a="http://schemas.openxmlformats.org/drawingml/2006/main">
               <a:ext uri="{FF2B5EF4-FFF2-40B4-BE49-F238E27FC236}">
-                <a16:creationId xmlns:a16="http://schemas.microsoft.com/office/drawing/2014/main" id="{B2D5D72A-3E84-4D18-9649-168849C1B7F8}"/>
+                <a16:creationId xmlns:a16="http://schemas.microsoft.com/office/drawing/2014/main" id="{49C06481-5549-4917-AEC5-62DFB0CC94EE}"/>
               </a:ext>
             </a:extLst>
           </p:cNvPr>
@@ -4199,7 +4199,7 @@
           <p:cNvPr id="2" name="">
             <a:extLst xmlns:a="http://schemas.openxmlformats.org/drawingml/2006/main">
               <a:ext uri="{FF2B5EF4-FFF2-40B4-BE49-F238E27FC236}">
-                <a16:creationId xmlns:a16="http://schemas.microsoft.com/office/drawing/2014/main" id="{15BA7559-3D6A-4881-BD1E-C69DC39C36AA}"/>
+                <a16:creationId xmlns:a16="http://schemas.microsoft.com/office/drawing/2014/main" id="{4E2BCD23-DA75-4528-9F9E-9086CB3B4C2B}"/>
               </a:ext>
             </a:extLst>
           </p:cNvPr>
@@ -4256,7 +4256,7 @@
           <p:cNvPr id="3" name="">
             <a:extLst xmlns:a="http://schemas.openxmlformats.org/drawingml/2006/main">
               <a:ext uri="{FF2B5EF4-FFF2-40B4-BE49-F238E27FC236}">
-                <a16:creationId xmlns:a16="http://schemas.microsoft.com/office/drawing/2014/main" id="{040586EC-0696-411A-A893-B936B39CA073}"/>
+                <a16:creationId xmlns:a16="http://schemas.microsoft.com/office/drawing/2014/main" id="{DDE997A7-C68B-4320-BC24-C35F2CBB3E53}"/>
               </a:ext>
             </a:extLst>
           </p:cNvPr>
@@ -4313,7 +4313,7 @@
           <p:cNvPr id="4" name="">
             <a:extLst xmlns:a="http://schemas.openxmlformats.org/drawingml/2006/main">
               <a:ext uri="{FF2B5EF4-FFF2-40B4-BE49-F238E27FC236}">
-                <a16:creationId xmlns:a16="http://schemas.microsoft.com/office/drawing/2014/main" id="{CE7809D0-BE96-4AD5-A47D-A4987FCC4DA4}"/>
+                <a16:creationId xmlns:a16="http://schemas.microsoft.com/office/drawing/2014/main" id="{598614B2-BAA4-4C0B-8BC0-1EFAC7E268B7}"/>
               </a:ext>
             </a:extLst>
           </p:cNvPr>
@@ -4370,7 +4370,7 @@
           <p:cNvPr id="5" name="">
             <a:extLst xmlns:a="http://schemas.openxmlformats.org/drawingml/2006/main">
               <a:ext uri="{FF2B5EF4-FFF2-40B4-BE49-F238E27FC236}">
-                <a16:creationId xmlns:a16="http://schemas.microsoft.com/office/drawing/2014/main" id="{AC45C9BC-E23C-4785-A088-8E3A60C4157E}"/>
+                <a16:creationId xmlns:a16="http://schemas.microsoft.com/office/drawing/2014/main" id="{FB3DBD89-0FF5-4976-B681-7B06352FB75A}"/>
               </a:ext>
             </a:extLst>
           </p:cNvPr>
@@ -4427,7 +4427,7 @@
           <p:cNvPr id="6" name="">
             <a:extLst xmlns:a="http://schemas.openxmlformats.org/drawingml/2006/main">
               <a:ext uri="{FF2B5EF4-FFF2-40B4-BE49-F238E27FC236}">
-                <a16:creationId xmlns:a16="http://schemas.microsoft.com/office/drawing/2014/main" id="{174CD96C-5699-43E4-BEFE-5AD22DEBFD9F}"/>
+                <a16:creationId xmlns:a16="http://schemas.microsoft.com/office/drawing/2014/main" id="{0817489C-46F4-44C0-B971-66021F444A19}"/>
               </a:ext>
             </a:extLst>
           </p:cNvPr>
@@ -4482,7 +4482,7 @@
     </p:spTree>
     <p:extLst>
       <p:ext uri="{BB962C8B-B14F-4D97-AF65-F5344CB8AC3E}">
-        <p14:creationId xmlns:p14="http://schemas.microsoft.com/office/powerpoint/2010/main" val="1924106149"/>
+        <p14:creationId xmlns:p14="http://schemas.microsoft.com/office/powerpoint/2010/main" val="1114842646"/>
       </p:ext>
     </p:extLst>
   </p:cSld>
@@ -4513,7 +4513,7 @@
           <p:cNvPr id="7" name="">
             <a:extLst xmlns:a="http://schemas.openxmlformats.org/drawingml/2006/main">
               <a:ext uri="{FF2B5EF4-FFF2-40B4-BE49-F238E27FC236}">
-                <a16:creationId xmlns:a16="http://schemas.microsoft.com/office/drawing/2014/main" id="{3C0E85C0-A4FC-46CF-BCC1-9EB6E38F44F9}"/>
+                <a16:creationId xmlns:a16="http://schemas.microsoft.com/office/drawing/2014/main" id="{A511F395-2695-418E-9CD5-196D9108F6E7}"/>
               </a:ext>
             </a:extLst>
           </p:cNvPr>
@@ -4570,7 +4570,7 @@
           <p:cNvPr id="2" name="">
             <a:extLst xmlns:a="http://schemas.openxmlformats.org/drawingml/2006/main">
               <a:ext uri="{FF2B5EF4-FFF2-40B4-BE49-F238E27FC236}">
-                <a16:creationId xmlns:a16="http://schemas.microsoft.com/office/drawing/2014/main" id="{95E321F8-5D43-498F-B8B6-8A1D61EBA09B}"/>
+                <a16:creationId xmlns:a16="http://schemas.microsoft.com/office/drawing/2014/main" id="{F45E03FB-FB7E-4624-9C9C-04AE91F11C82}"/>
               </a:ext>
             </a:extLst>
           </p:cNvPr>
@@ -4627,7 +4627,7 @@
           <p:cNvPr id="3" name="">
             <a:extLst xmlns:a="http://schemas.openxmlformats.org/drawingml/2006/main">
               <a:ext uri="{FF2B5EF4-FFF2-40B4-BE49-F238E27FC236}">
-                <a16:creationId xmlns:a16="http://schemas.microsoft.com/office/drawing/2014/main" id="{81061C3D-90B9-4F8B-A7D7-887C4A0FAA54}"/>
+                <a16:creationId xmlns:a16="http://schemas.microsoft.com/office/drawing/2014/main" id="{EF2A2FA9-1866-48A7-8A23-F689E7A43EE9}"/>
               </a:ext>
             </a:extLst>
           </p:cNvPr>
@@ -4684,7 +4684,7 @@
           <p:cNvPr id="4" name="">
             <a:extLst xmlns:a="http://schemas.openxmlformats.org/drawingml/2006/main">
               <a:ext uri="{FF2B5EF4-FFF2-40B4-BE49-F238E27FC236}">
-                <a16:creationId xmlns:a16="http://schemas.microsoft.com/office/drawing/2014/main" id="{751DE9B6-CD69-409D-BDBD-FCD2BC460974}"/>
+                <a16:creationId xmlns:a16="http://schemas.microsoft.com/office/drawing/2014/main" id="{BA652C1C-6876-4692-964F-889D84804BA6}"/>
               </a:ext>
             </a:extLst>
           </p:cNvPr>
@@ -4741,7 +4741,7 @@
           <p:cNvPr id="5" name="">
             <a:extLst xmlns:a="http://schemas.openxmlformats.org/drawingml/2006/main">
               <a:ext uri="{FF2B5EF4-FFF2-40B4-BE49-F238E27FC236}">
-                <a16:creationId xmlns:a16="http://schemas.microsoft.com/office/drawing/2014/main" id="{4B2118ED-13A9-4B4E-9F61-CCC68CEA44BA}"/>
+                <a16:creationId xmlns:a16="http://schemas.microsoft.com/office/drawing/2014/main" id="{C3ED864F-1004-4C8A-B002-9D1057D9953B}"/>
               </a:ext>
             </a:extLst>
           </p:cNvPr>
@@ -4798,7 +4798,7 @@
           <p:cNvPr id="6" name="">
             <a:extLst xmlns:a="http://schemas.openxmlformats.org/drawingml/2006/main">
               <a:ext uri="{FF2B5EF4-FFF2-40B4-BE49-F238E27FC236}">
-                <a16:creationId xmlns:a16="http://schemas.microsoft.com/office/drawing/2014/main" id="{601A9D13-3552-4CA0-8E55-AA4B6B2A06F2}"/>
+                <a16:creationId xmlns:a16="http://schemas.microsoft.com/office/drawing/2014/main" id="{D2E7B30A-BA7C-4E7B-ACAB-735A4677256D}"/>
               </a:ext>
             </a:extLst>
           </p:cNvPr>
@@ -4853,7 +4853,7 @@
     </p:spTree>
     <p:extLst>
       <p:ext uri="{BB962C8B-B14F-4D97-AF65-F5344CB8AC3E}">
-        <p14:creationId xmlns:p14="http://schemas.microsoft.com/office/powerpoint/2010/main" val="1122803469"/>
+        <p14:creationId xmlns:p14="http://schemas.microsoft.com/office/powerpoint/2010/main" val="340988831"/>
       </p:ext>
     </p:extLst>
   </p:cSld>
@@ -4884,7 +4884,7 @@
           <p:cNvPr id="5" name="">
             <a:extLst xmlns:a="http://schemas.openxmlformats.org/drawingml/2006/main">
               <a:ext uri="{FF2B5EF4-FFF2-40B4-BE49-F238E27FC236}">
-                <a16:creationId xmlns:a16="http://schemas.microsoft.com/office/drawing/2014/main" id="{2FC1EAAD-D57D-48C0-80DF-09BEE2E13A1A}"/>
+                <a16:creationId xmlns:a16="http://schemas.microsoft.com/office/drawing/2014/main" id="{C4485657-3B0E-4FFB-81EB-B045AA7D48C4}"/>
               </a:ext>
             </a:extLst>
           </p:cNvPr>
@@ -4948,7 +4948,7 @@
         </p:xfrm>
         <a:graphic xmlns:a="http://schemas.openxmlformats.org/drawingml/2006/main">
           <a:graphicData uri="http://schemas.openxmlformats.org/drawingml/2006/chart">
-            <c:chart xmlns:r="http://schemas.openxmlformats.org/officeDocument/2006/relationships" xmlns:c="http://schemas.openxmlformats.org/drawingml/2006/chart" r:id="R8d9880717cc94399"/>
+            <c:chart xmlns:r="http://schemas.openxmlformats.org/officeDocument/2006/relationships" xmlns:c="http://schemas.openxmlformats.org/drawingml/2006/chart" r:id="Rb04831d5001f4741"/>
           </a:graphicData>
         </a:graphic>
       </p:graphicFrame>
@@ -4957,7 +4957,7 @@
           <p:cNvPr id="3" name="">
             <a:extLst xmlns:a="http://schemas.openxmlformats.org/drawingml/2006/main">
               <a:ext uri="{FF2B5EF4-FFF2-40B4-BE49-F238E27FC236}">
-                <a16:creationId xmlns:a16="http://schemas.microsoft.com/office/drawing/2014/main" id="{01439A39-0BB0-4F5C-8D81-4C70EE63B692}"/>
+                <a16:creationId xmlns:a16="http://schemas.microsoft.com/office/drawing/2014/main" id="{FF32DC05-4126-48CD-A802-17FF1850EC6D}"/>
               </a:ext>
             </a:extLst>
           </p:cNvPr>
@@ -5014,7 +5014,7 @@
           <p:cNvPr id="4" name="">
             <a:extLst xmlns:a="http://schemas.openxmlformats.org/drawingml/2006/main">
               <a:ext uri="{FF2B5EF4-FFF2-40B4-BE49-F238E27FC236}">
-                <a16:creationId xmlns:a16="http://schemas.microsoft.com/office/drawing/2014/main" id="{25C81AD7-DC92-4111-8F24-B76EC3C901BF}"/>
+                <a16:creationId xmlns:a16="http://schemas.microsoft.com/office/drawing/2014/main" id="{7EC29A5E-952E-454C-9C68-C5BB32AC09BD}"/>
               </a:ext>
             </a:extLst>
           </p:cNvPr>
@@ -5069,7 +5069,7 @@
     </p:spTree>
     <p:extLst>
       <p:ext uri="{BB962C8B-B14F-4D97-AF65-F5344CB8AC3E}">
-        <p14:creationId xmlns:p14="http://schemas.microsoft.com/office/powerpoint/2010/main" val="1178199020"/>
+        <p14:creationId xmlns:p14="http://schemas.microsoft.com/office/powerpoint/2010/main" val="327769995"/>
       </p:ext>
     </p:extLst>
   </p:cSld>
@@ -5100,7 +5100,7 @@
           <p:cNvPr id="7" name="">
             <a:extLst xmlns:a="http://schemas.openxmlformats.org/drawingml/2006/main">
               <a:ext uri="{FF2B5EF4-FFF2-40B4-BE49-F238E27FC236}">
-                <a16:creationId xmlns:a16="http://schemas.microsoft.com/office/drawing/2014/main" id="{E54613BF-8364-4A2A-9E67-12D9BEFA76ED}"/>
+                <a16:creationId xmlns:a16="http://schemas.microsoft.com/office/drawing/2014/main" id="{47952DF4-2D64-4269-AC85-B63CD4DA7190}"/>
               </a:ext>
             </a:extLst>
           </p:cNvPr>
@@ -5157,7 +5157,7 @@
           <p:cNvPr id="2" name="">
             <a:extLst xmlns:a="http://schemas.openxmlformats.org/drawingml/2006/main">
               <a:ext uri="{FF2B5EF4-FFF2-40B4-BE49-F238E27FC236}">
-                <a16:creationId xmlns:a16="http://schemas.microsoft.com/office/drawing/2014/main" id="{84F1BF14-1EB1-42B9-8E4E-0426239354CF}"/>
+                <a16:creationId xmlns:a16="http://schemas.microsoft.com/office/drawing/2014/main" id="{26E89F25-6F31-48B3-992D-0ABA329FF249}"/>
               </a:ext>
             </a:extLst>
           </p:cNvPr>
@@ -5214,7 +5214,7 @@
           <p:cNvPr id="3" name="">
             <a:extLst xmlns:a="http://schemas.openxmlformats.org/drawingml/2006/main">
               <a:ext uri="{FF2B5EF4-FFF2-40B4-BE49-F238E27FC236}">
-                <a16:creationId xmlns:a16="http://schemas.microsoft.com/office/drawing/2014/main" id="{E74DA740-4DA5-4022-B4DC-5A890E707A50}"/>
+                <a16:creationId xmlns:a16="http://schemas.microsoft.com/office/drawing/2014/main" id="{CCE7BD6B-F13B-4561-A05D-D76EAF5C8AA1}"/>
               </a:ext>
             </a:extLst>
           </p:cNvPr>
@@ -5271,7 +5271,7 @@
           <p:cNvPr id="4" name="">
             <a:extLst xmlns:a="http://schemas.openxmlformats.org/drawingml/2006/main">
               <a:ext uri="{FF2B5EF4-FFF2-40B4-BE49-F238E27FC236}">
-                <a16:creationId xmlns:a16="http://schemas.microsoft.com/office/drawing/2014/main" id="{6BFD3EC9-A373-4858-85BC-07A85196D8FC}"/>
+                <a16:creationId xmlns:a16="http://schemas.microsoft.com/office/drawing/2014/main" id="{5B195307-660C-44B2-84F9-F38EE6C04941}"/>
               </a:ext>
             </a:extLst>
           </p:cNvPr>
@@ -5328,7 +5328,7 @@
           <p:cNvPr id="5" name="">
             <a:extLst xmlns:a="http://schemas.openxmlformats.org/drawingml/2006/main">
               <a:ext uri="{FF2B5EF4-FFF2-40B4-BE49-F238E27FC236}">
-                <a16:creationId xmlns:a16="http://schemas.microsoft.com/office/drawing/2014/main" id="{7571D0CE-4BC8-4FF9-85BD-A53A14CE8C26}"/>
+                <a16:creationId xmlns:a16="http://schemas.microsoft.com/office/drawing/2014/main" id="{60C4B635-FFBA-489F-A365-2F78A60B7CFC}"/>
               </a:ext>
             </a:extLst>
           </p:cNvPr>
@@ -5385,7 +5385,7 @@
           <p:cNvPr id="6" name="">
             <a:extLst xmlns:a="http://schemas.openxmlformats.org/drawingml/2006/main">
               <a:ext uri="{FF2B5EF4-FFF2-40B4-BE49-F238E27FC236}">
-                <a16:creationId xmlns:a16="http://schemas.microsoft.com/office/drawing/2014/main" id="{08985DE4-1E5E-42B5-A0B4-EDDD08802F22}"/>
+                <a16:creationId xmlns:a16="http://schemas.microsoft.com/office/drawing/2014/main" id="{E1953F76-04F2-43AA-A199-9C1B7B904DE1}"/>
               </a:ext>
             </a:extLst>
           </p:cNvPr>
@@ -5440,7 +5440,7 @@
     </p:spTree>
     <p:extLst>
       <p:ext uri="{BB962C8B-B14F-4D97-AF65-F5344CB8AC3E}">
-        <p14:creationId xmlns:p14="http://schemas.microsoft.com/office/powerpoint/2010/main" val="1139199885"/>
+        <p14:creationId xmlns:p14="http://schemas.microsoft.com/office/powerpoint/2010/main" val="895809637"/>
       </p:ext>
     </p:extLst>
   </p:cSld>
@@ -5471,7 +5471,7 @@
           <p:cNvPr id="5" name="">
             <a:extLst xmlns:a="http://schemas.openxmlformats.org/drawingml/2006/main">
               <a:ext uri="{FF2B5EF4-FFF2-40B4-BE49-F238E27FC236}">
-                <a16:creationId xmlns:a16="http://schemas.microsoft.com/office/drawing/2014/main" id="{EB603055-CCB1-4F9D-AE47-F7E240151C02}"/>
+                <a16:creationId xmlns:a16="http://schemas.microsoft.com/office/drawing/2014/main" id="{C73F8B7D-DC8E-42CF-99FA-54E0A8811E5F}"/>
               </a:ext>
             </a:extLst>
           </p:cNvPr>
@@ -5535,7 +5535,7 @@
         </p:xfrm>
         <a:graphic xmlns:a="http://schemas.openxmlformats.org/drawingml/2006/main">
           <a:graphicData uri="http://schemas.openxmlformats.org/drawingml/2006/chart">
-            <c:chart xmlns:r="http://schemas.openxmlformats.org/officeDocument/2006/relationships" xmlns:c="http://schemas.openxmlformats.org/drawingml/2006/chart" r:id="Rfcd466d1d64a4553"/>
+            <c:chart xmlns:r="http://schemas.openxmlformats.org/officeDocument/2006/relationships" xmlns:c="http://schemas.openxmlformats.org/drawingml/2006/chart" r:id="Rd3a6c5b17a734422"/>
           </a:graphicData>
         </a:graphic>
       </p:graphicFrame>
@@ -5544,7 +5544,7 @@
           <p:cNvPr id="3" name="">
             <a:extLst xmlns:a="http://schemas.openxmlformats.org/drawingml/2006/main">
               <a:ext uri="{FF2B5EF4-FFF2-40B4-BE49-F238E27FC236}">
-                <a16:creationId xmlns:a16="http://schemas.microsoft.com/office/drawing/2014/main" id="{E1B58304-674F-4F38-84E2-057E9C4EFF99}"/>
+                <a16:creationId xmlns:a16="http://schemas.microsoft.com/office/drawing/2014/main" id="{5466D784-6928-471E-A001-E732F4B217A1}"/>
               </a:ext>
             </a:extLst>
           </p:cNvPr>
@@ -5601,7 +5601,7 @@
           <p:cNvPr id="4" name="">
             <a:extLst xmlns:a="http://schemas.openxmlformats.org/drawingml/2006/main">
               <a:ext uri="{FF2B5EF4-FFF2-40B4-BE49-F238E27FC236}">
-                <a16:creationId xmlns:a16="http://schemas.microsoft.com/office/drawing/2014/main" id="{DC7BE9D6-54B5-4ECA-AFE8-C7658A72CB9D}"/>
+                <a16:creationId xmlns:a16="http://schemas.microsoft.com/office/drawing/2014/main" id="{67C39BAF-C5CC-4A85-A116-F079E593E612}"/>
               </a:ext>
             </a:extLst>
           </p:cNvPr>
@@ -5656,7 +5656,7 @@
     </p:spTree>
     <p:extLst>
       <p:ext uri="{BB962C8B-B14F-4D97-AF65-F5344CB8AC3E}">
-        <p14:creationId xmlns:p14="http://schemas.microsoft.com/office/powerpoint/2010/main" val="1025344113"/>
+        <p14:creationId xmlns:p14="http://schemas.microsoft.com/office/powerpoint/2010/main" val="415119484"/>
       </p:ext>
     </p:extLst>
   </p:cSld>
@@ -5687,7 +5687,7 @@
           <p:cNvPr id="7" name="">
             <a:extLst xmlns:a="http://schemas.openxmlformats.org/drawingml/2006/main">
               <a:ext uri="{FF2B5EF4-FFF2-40B4-BE49-F238E27FC236}">
-                <a16:creationId xmlns:a16="http://schemas.microsoft.com/office/drawing/2014/main" id="{B4C52439-2E83-46E4-AECD-D09AF8719DB4}"/>
+                <a16:creationId xmlns:a16="http://schemas.microsoft.com/office/drawing/2014/main" id="{E9C19A69-415D-4D7E-BC8A-B926C31A1486}"/>
               </a:ext>
             </a:extLst>
           </p:cNvPr>
@@ -5744,7 +5744,7 @@
           <p:cNvPr id="2" name="">
             <a:extLst xmlns:a="http://schemas.openxmlformats.org/drawingml/2006/main">
               <a:ext uri="{FF2B5EF4-FFF2-40B4-BE49-F238E27FC236}">
-                <a16:creationId xmlns:a16="http://schemas.microsoft.com/office/drawing/2014/main" id="{4892219D-296D-447D-88DA-2C7DF26B5727}"/>
+                <a16:creationId xmlns:a16="http://schemas.microsoft.com/office/drawing/2014/main" id="{D3F65564-0244-42CF-ACD9-7CB92B76493D}"/>
               </a:ext>
             </a:extLst>
           </p:cNvPr>
@@ -5801,7 +5801,7 @@
           <p:cNvPr id="3" name="">
             <a:extLst xmlns:a="http://schemas.openxmlformats.org/drawingml/2006/main">
               <a:ext uri="{FF2B5EF4-FFF2-40B4-BE49-F238E27FC236}">
-                <a16:creationId xmlns:a16="http://schemas.microsoft.com/office/drawing/2014/main" id="{EF53B5E4-B503-4866-BC04-4F59C376CBAF}"/>
+                <a16:creationId xmlns:a16="http://schemas.microsoft.com/office/drawing/2014/main" id="{94271407-D4E1-4751-AC4B-FDC6F62FE6E2}"/>
               </a:ext>
             </a:extLst>
           </p:cNvPr>
@@ -5858,7 +5858,7 @@
           <p:cNvPr id="4" name="">
             <a:extLst xmlns:a="http://schemas.openxmlformats.org/drawingml/2006/main">
               <a:ext uri="{FF2B5EF4-FFF2-40B4-BE49-F238E27FC236}">
-                <a16:creationId xmlns:a16="http://schemas.microsoft.com/office/drawing/2014/main" id="{719EB4BE-7CAF-4778-AE95-CBEAF0087838}"/>
+                <a16:creationId xmlns:a16="http://schemas.microsoft.com/office/drawing/2014/main" id="{E3C3C014-8163-421B-B558-9F539BF41385}"/>
               </a:ext>
             </a:extLst>
           </p:cNvPr>
@@ -5905,7 +5905,7 @@
                 <a:ea typeface="Arial"/>
                 <a:cs typeface="Arial"/>
               </a:rPr>
-              <a:t>Оператор отвечает за резерв, финансирующая сторона — за инвестиционные ворота.</a:t>
+              <a:t>EXP-07–10: обратный стресс, меры защиты, задержка Earth-New и Монте-Карло.</a:t>
             </a:r>
           </a:p>
         </p:txBody>
@@ -5915,7 +5915,7 @@
           <p:cNvPr id="5" name="">
             <a:extLst xmlns:a="http://schemas.openxmlformats.org/drawingml/2006/main">
               <a:ext uri="{FF2B5EF4-FFF2-40B4-BE49-F238E27FC236}">
-                <a16:creationId xmlns:a16="http://schemas.microsoft.com/office/drawing/2014/main" id="{09272C64-4DC1-4890-A692-3928183C86AF}"/>
+                <a16:creationId xmlns:a16="http://schemas.microsoft.com/office/drawing/2014/main" id="{5451891A-0A15-4787-A412-CA879D76CFE7}"/>
               </a:ext>
             </a:extLst>
           </p:cNvPr>
@@ -5962,7 +5962,7 @@
                 <a:ea typeface="Arial"/>
                 <a:cs typeface="Arial"/>
               </a:rPr>
-              <a:t>Обратный стресс и Монте-Карло пока не реализованы. Итоговый выбор стратегии остаётся за R2/R3.</a:t>
+              <a:t>Монте-Карло: N = 10 000, seed = 203510. Распределения TEAM_ASSUMPTION, вероятности не калиброваны.</a:t>
             </a:r>
           </a:p>
         </p:txBody>
@@ -5972,7 +5972,7 @@
           <p:cNvPr id="6" name="">
             <a:extLst xmlns:a="http://schemas.openxmlformats.org/drawingml/2006/main">
               <a:ext uri="{FF2B5EF4-FFF2-40B4-BE49-F238E27FC236}">
-                <a16:creationId xmlns:a16="http://schemas.microsoft.com/office/drawing/2014/main" id="{AD544946-B9A6-415C-BF6E-56860860CB35}"/>
+                <a16:creationId xmlns:a16="http://schemas.microsoft.com/office/drawing/2014/main" id="{E1195AB7-1BE0-47BB-91BC-CF17BFEE3849}"/>
               </a:ext>
             </a:extLst>
           </p:cNvPr>
@@ -6027,7 +6027,7 @@
     </p:spTree>
     <p:extLst>
       <p:ext uri="{BB962C8B-B14F-4D97-AF65-F5344CB8AC3E}">
-        <p14:creationId xmlns:p14="http://schemas.microsoft.com/office/powerpoint/2010/main" val="1089084539"/>
+        <p14:creationId xmlns:p14="http://schemas.microsoft.com/office/powerpoint/2010/main" val="944723498"/>
       </p:ext>
     </p:extLst>
   </p:cSld>
@@ -6058,7 +6058,7 @@
           <p:cNvPr id="7" name="">
             <a:extLst xmlns:a="http://schemas.openxmlformats.org/drawingml/2006/main">
               <a:ext uri="{FF2B5EF4-FFF2-40B4-BE49-F238E27FC236}">
-                <a16:creationId xmlns:a16="http://schemas.microsoft.com/office/drawing/2014/main" id="{5D3E3FAE-C372-4472-B709-2A42BB4BA945}"/>
+                <a16:creationId xmlns:a16="http://schemas.microsoft.com/office/drawing/2014/main" id="{C6AAE3CA-32BC-4D36-8AA7-76E5B543E9A9}"/>
               </a:ext>
             </a:extLst>
           </p:cNvPr>
@@ -6115,7 +6115,7 @@
           <p:cNvPr id="2" name="">
             <a:extLst xmlns:a="http://schemas.openxmlformats.org/drawingml/2006/main">
               <a:ext uri="{FF2B5EF4-FFF2-40B4-BE49-F238E27FC236}">
-                <a16:creationId xmlns:a16="http://schemas.microsoft.com/office/drawing/2014/main" id="{6F7A8917-68FF-4C71-8721-85113083469C}"/>
+                <a16:creationId xmlns:a16="http://schemas.microsoft.com/office/drawing/2014/main" id="{F04C2462-D70B-4223-87B5-3C2B47345170}"/>
               </a:ext>
             </a:extLst>
           </p:cNvPr>
@@ -6172,7 +6172,7 @@
           <p:cNvPr id="3" name="">
             <a:extLst xmlns:a="http://schemas.openxmlformats.org/drawingml/2006/main">
               <a:ext uri="{FF2B5EF4-FFF2-40B4-BE49-F238E27FC236}">
-                <a16:creationId xmlns:a16="http://schemas.microsoft.com/office/drawing/2014/main" id="{94779261-76EE-493C-8952-F8467D6B7F92}"/>
+                <a16:creationId xmlns:a16="http://schemas.microsoft.com/office/drawing/2014/main" id="{5CDD37DF-D081-443C-B512-CDBE9EDADBD1}"/>
               </a:ext>
             </a:extLst>
           </p:cNvPr>
@@ -6229,7 +6229,7 @@
           <p:cNvPr id="4" name="">
             <a:extLst xmlns:a="http://schemas.openxmlformats.org/drawingml/2006/main">
               <a:ext uri="{FF2B5EF4-FFF2-40B4-BE49-F238E27FC236}">
-                <a16:creationId xmlns:a16="http://schemas.microsoft.com/office/drawing/2014/main" id="{AB19A643-6D09-4ADD-874A-D97D46CEDD4C}"/>
+                <a16:creationId xmlns:a16="http://schemas.microsoft.com/office/drawing/2014/main" id="{448D663C-7DC5-4C35-B481-B546DF52C518}"/>
               </a:ext>
             </a:extLst>
           </p:cNvPr>
@@ -6286,7 +6286,7 @@
           <p:cNvPr id="5" name="">
             <a:extLst xmlns:a="http://schemas.openxmlformats.org/drawingml/2006/main">
               <a:ext uri="{FF2B5EF4-FFF2-40B4-BE49-F238E27FC236}">
-                <a16:creationId xmlns:a16="http://schemas.microsoft.com/office/drawing/2014/main" id="{84295A83-DD30-4F6E-BCB9-EBE9A42D213B}"/>
+                <a16:creationId xmlns:a16="http://schemas.microsoft.com/office/drawing/2014/main" id="{BF10EA79-DDFC-4572-9228-8394BDFC79EF}"/>
               </a:ext>
             </a:extLst>
           </p:cNvPr>
@@ -6343,7 +6343,7 @@
           <p:cNvPr id="6" name="">
             <a:extLst xmlns:a="http://schemas.openxmlformats.org/drawingml/2006/main">
               <a:ext uri="{FF2B5EF4-FFF2-40B4-BE49-F238E27FC236}">
-                <a16:creationId xmlns:a16="http://schemas.microsoft.com/office/drawing/2014/main" id="{68EB654D-BBD5-490F-8DA5-12B43FC0DFEA}"/>
+                <a16:creationId xmlns:a16="http://schemas.microsoft.com/office/drawing/2014/main" id="{7BD4E147-E151-4D54-A76A-41A5A6391BB3}"/>
               </a:ext>
             </a:extLst>
           </p:cNvPr>
@@ -6398,7 +6398,7 @@
     </p:spTree>
     <p:extLst>
       <p:ext uri="{BB962C8B-B14F-4D97-AF65-F5344CB8AC3E}">
-        <p14:creationId xmlns:p14="http://schemas.microsoft.com/office/powerpoint/2010/main" val="236902631"/>
+        <p14:creationId xmlns:p14="http://schemas.microsoft.com/office/powerpoint/2010/main" val="1855393947"/>
       </p:ext>
     </p:extLst>
   </p:cSld>

</xml_diff>

<commit_message>
R4: align UI and presentation with selected P2z strategy
</commit_message>
<xml_diff>
--- a/docs/presentation/TerraPlan.pptx
+++ b/docs/presentation/TerraPlan.pptx
@@ -2,24 +2,24 @@
 <file path=ppt/presentation.xml><?xml version="1.0" encoding="utf-8"?>
 <p:presentation xmlns:p="http://schemas.openxmlformats.org/presentationml/2006/main">
   <p:sldMasterIdLst>
-    <p:sldMasterId xmlns:r="http://schemas.openxmlformats.org/officeDocument/2006/relationships" id="2147483648" r:id="R2023d563f7ff4921"/>
+    <p:sldMasterId xmlns:r="http://schemas.openxmlformats.org/officeDocument/2006/relationships" id="2147483648" r:id="R9af45324990f4fc6"/>
   </p:sldMasterIdLst>
   <p:notesMasterIdLst>
-    <p:notesMasterId xmlns:r="http://schemas.openxmlformats.org/officeDocument/2006/relationships" r:id="R21a948751204462d"/>
+    <p:notesMasterId xmlns:r="http://schemas.openxmlformats.org/officeDocument/2006/relationships" r:id="Rb85f8279411d4f74"/>
   </p:notesMasterIdLst>
   <p:sldIdLst>
-    <p:sldId xmlns:r="http://schemas.openxmlformats.org/officeDocument/2006/relationships" id="256" r:id="R15053188c359436b"/>
-    <p:sldId xmlns:r="http://schemas.openxmlformats.org/officeDocument/2006/relationships" id="257" r:id="R44b923eed6144a09"/>
-    <p:sldId xmlns:r="http://schemas.openxmlformats.org/officeDocument/2006/relationships" id="258" r:id="R31f42144eab149de"/>
-    <p:sldId xmlns:r="http://schemas.openxmlformats.org/officeDocument/2006/relationships" id="259" r:id="R493f4c2679214315"/>
-    <p:sldId xmlns:r="http://schemas.openxmlformats.org/officeDocument/2006/relationships" id="260" r:id="R554e14916dfe40cb"/>
-    <p:sldId xmlns:r="http://schemas.openxmlformats.org/officeDocument/2006/relationships" id="261" r:id="Rc32323d9c22e4ac3"/>
-    <p:sldId xmlns:r="http://schemas.openxmlformats.org/officeDocument/2006/relationships" id="262" r:id="R14af91ec1f564223"/>
-    <p:sldId xmlns:r="http://schemas.openxmlformats.org/officeDocument/2006/relationships" id="263" r:id="R8537768d8f3b43f9"/>
-    <p:sldId xmlns:r="http://schemas.openxmlformats.org/officeDocument/2006/relationships" id="264" r:id="R407982ae1d6b4119"/>
-    <p:sldId xmlns:r="http://schemas.openxmlformats.org/officeDocument/2006/relationships" id="265" r:id="R0d5f49da9c0b4fbe"/>
-    <p:sldId xmlns:r="http://schemas.openxmlformats.org/officeDocument/2006/relationships" id="266" r:id="Rb9140e545f684ddb"/>
-    <p:sldId xmlns:r="http://schemas.openxmlformats.org/officeDocument/2006/relationships" id="267" r:id="R3f6c89bbc7314911"/>
+    <p:sldId xmlns:r="http://schemas.openxmlformats.org/officeDocument/2006/relationships" id="256" r:id="R681ccfb02e394586"/>
+    <p:sldId xmlns:r="http://schemas.openxmlformats.org/officeDocument/2006/relationships" id="257" r:id="Ra0e4bb68edda4b7b"/>
+    <p:sldId xmlns:r="http://schemas.openxmlformats.org/officeDocument/2006/relationships" id="258" r:id="Rddf43518366448e3"/>
+    <p:sldId xmlns:r="http://schemas.openxmlformats.org/officeDocument/2006/relationships" id="259" r:id="R873b82303fd74dd4"/>
+    <p:sldId xmlns:r="http://schemas.openxmlformats.org/officeDocument/2006/relationships" id="260" r:id="R59a7dad92ae340ea"/>
+    <p:sldId xmlns:r="http://schemas.openxmlformats.org/officeDocument/2006/relationships" id="261" r:id="Rdc08a1352f094f01"/>
+    <p:sldId xmlns:r="http://schemas.openxmlformats.org/officeDocument/2006/relationships" id="262" r:id="Reefedf964b6647e0"/>
+    <p:sldId xmlns:r="http://schemas.openxmlformats.org/officeDocument/2006/relationships" id="263" r:id="Rcf0ec0ee1c764f45"/>
+    <p:sldId xmlns:r="http://schemas.openxmlformats.org/officeDocument/2006/relationships" id="264" r:id="Rc288a6972b1647fe"/>
+    <p:sldId xmlns:r="http://schemas.openxmlformats.org/officeDocument/2006/relationships" id="265" r:id="Rfb8f31821fcb475b"/>
+    <p:sldId xmlns:r="http://schemas.openxmlformats.org/officeDocument/2006/relationships" id="266" r:id="R7b3841cf60a44ee1"/>
+    <p:sldId xmlns:r="http://schemas.openxmlformats.org/officeDocument/2006/relationships" id="267" r:id="Ra3d84099d22f4f4f"/>
   </p:sldIdLst>
   <p:sldSz cx="12192000" cy="6858000"/>
   <p:notesSz cx="6858000" cy="9144000"/>
@@ -593,7 +593,7 @@
           <a:lstStyle xmlns:a="http://schemas.openxmlformats.org/drawingml/2006/main"/>
           <a:p xmlns:a="http://schemas.openxmlformats.org/drawingml/2006/main">
             <a:r>
-              <a:t>Источники в репозитории: results/alternatives/P3_isru_zbo_BASE/financial_breakdown.csv; docs/roadmap_budget.md. Все денежные показатели в млн условных единиц, постоянные цены 2035 г. Значения диаграмм округлены до целого, исходные точные значения сохранены в result.json.</a:t>
+              <a:t>Источники в репозитории: results/alternatives/P2z_earth_new_zbo_BASE/financial_breakdown.csv; docs/roadmap_budget.md. Все денежные показатели в млн условных единиц, постоянные цены 2035 г. Значения диаграмм округлены до целого, исходные точные значения сохранены в result.json.</a:t>
             </a:r>
           </a:p>
         </p:txBody>
@@ -943,7 +943,7 @@
           <a:lstStyle xmlns:a="http://schemas.openxmlformats.org/drawingml/2006/main"/>
           <a:p xmlns:a="http://schemas.openxmlformats.org/drawingml/2006/main">
             <a:r>
-              <a:t>Источники в репозитории: results/alternatives/*_BASE/result.json. Все денежные показатели в млн условных единиц, постоянные цены 2035 г. Значения диаграмм округлены до целого, исходные точные значения сохранены в result.json.</a:t>
+              <a:t>Источники в репозитории: results/alternatives/*_BASE/result.json; results/strategy/summary.md. Все денежные показатели в млн условных единиц, постоянные цены 2035 г. Значения диаграмм округлены до целого, исходные точные значения сохранены в result.json.</a:t>
             </a:r>
           </a:p>
         </p:txBody>
@@ -1013,7 +1013,7 @@
           <a:lstStyle xmlns:a="http://schemas.openxmlformats.org/drawingml/2006/main"/>
           <a:p xmlns:a="http://schemas.openxmlformats.org/drawingml/2006/main">
             <a:r>
-              <a:t>Источники в репозитории: results/alternatives/P3_isru_zbo_MANDATORY_STRESS/result.json; configs/scenarios/mandatory_stress.yaml. Все денежные показатели в млн условных единиц, постоянные цены 2035 г. Значения диаграмм округлены до целого, исходные точные значения сохранены в result.json.</a:t>
+              <a:t>Источники в репозитории: results/alternatives/P2z_earth_new_zbo_MANDATORY_STRESS/result.json; configs/scenarios/mandatory_stress.yaml. Все денежные показатели в млн условных единиц, постоянные цены 2035 г. Значения диаграмм округлены до целого, исходные точные значения сохранены в result.json.</a:t>
             </a:r>
           </a:p>
         </p:txBody>
@@ -1083,7 +1083,7 @@
           <a:lstStyle xmlns:a="http://schemas.openxmlformats.org/drawingml/2006/main"/>
           <a:p xmlns:a="http://schemas.openxmlformats.org/drawingml/2006/main">
             <a:r>
-              <a:t>Источники в репозитории: results/alternatives/P3_isru_zbo_BASE/result.json; results/alternatives/P3_isru_zbo_MANDATORY_STRESS/result.json; results/stress/P3_isru_zbo_adapted_MANDATORY_STRESS/result.json. Все денежные показатели в млн условных единиц, постоянные цены 2035 г. Значения диаграмм округлены до целого, исходные точные значения сохранены в result.json.</a:t>
+              <a:t>Источники в репозитории: results/alternatives/P2z_earth_new_zbo_BASE/result.json; results/alternatives/P2z_earth_new_zbo_MANDATORY_STRESS/result.json; results/stress/P2z_earth_new_zbo_adapted_MANDATORY_STRESS/result.json. Все денежные показатели в млн условных единиц, постоянные цены 2035 г. Значения диаграмм округлены до целого, исходные точные значения сохранены в result.json.</a:t>
             </a:r>
           </a:p>
         </p:txBody>
@@ -1153,7 +1153,7 @@
           <a:lstStyle xmlns:a="http://schemas.openxmlformats.org/drawingml/2006/main"/>
           <a:p xmlns:a="http://schemas.openxmlformats.org/drawingml/2006/main">
             <a:r>
-              <a:t>Источники в репозитории: results/reaction/summary.md; results/monte_carlo/summary.md; docs/risk_register.md; docs/stakeholders.md. Все денежные показатели в млн условных единиц, постоянные цены 2035 г. Значения диаграмм округлены до целого, исходные точные значения сохранены в result.json.</a:t>
+              <a:t>Источники в репозитории: results/earth_new_delay/summary.md; results/geopolitical_price_shock/summary.md; results/monte_carlo/summary.md. Все денежные показатели в млн условных единиц, постоянные цены 2035 г. Значения диаграмм округлены до целого, исходные точные значения сохранены в result.json.</a:t>
             </a:r>
           </a:p>
         </p:txBody>
@@ -1291,7 +1291,7 @@
   </p:cSld>
   <p:clrMap bg1="lt1" tx1="dk1" bg2="lt2" tx2="dk2" accent1="accent1" accent2="accent2" accent3="accent3" accent4="accent4" accent5="accent5" accent6="accent6" hlink="hlink" folHlink="folHlink"/>
   <p:sldLayoutIdLst>
-    <p:sldLayoutId xmlns:r="http://schemas.openxmlformats.org/officeDocument/2006/relationships" id="2147483649" r:id="R151a49f27fbf493f"/>
+    <p:sldLayoutId xmlns:r="http://schemas.openxmlformats.org/officeDocument/2006/relationships" id="2147483649" r:id="Rfc2a1d9c09134dd5"/>
   </p:sldLayoutIdLst>
   <p:txStyles>
     <p:titleStyle>
@@ -1831,7 +1831,7 @@
           <c:idx val="0"/>
           <c:order val="0"/>
           <c:tx>
-            <c:v>PV, млн у.е.</c:v>
+            <c:v>PV BASE, млн у.е.</c:v>
           </c:tx>
           <c:spPr>
             <a:solidFill xmlns:a="http://schemas.openxmlformats.org/drawingml/2006/main">
@@ -2032,13 +2032,13 @@
                 <c:formatCode>#,##0</c:formatCode>
                 <c:ptCount val="3"/>
                 <c:pt idx="0">
-                  <c:v>8639</c:v>
+                  <c:v>8729</c:v>
                 </c:pt>
                 <c:pt idx="1">
-                  <c:v>9032</c:v>
+                  <c:v>9143</c:v>
                 </c:pt>
                 <c:pt idx="2">
-                  <c:v>10637</c:v>
+                  <c:v>10097</c:v>
                 </c:pt>
               </c:numCache>
             </c:numRef>
@@ -2206,22 +2206,22 @@
                 <c:formatCode>#,##0</c:formatCode>
                 <c:ptCount val="6"/>
                 <c:pt idx="0">
-                  <c:v>858</c:v>
+                  <c:v>1218</c:v>
                 </c:pt>
                 <c:pt idx="1">
-                  <c:v>2282</c:v>
+                  <c:v>1032</c:v>
                 </c:pt>
                 <c:pt idx="2">
-                  <c:v>1588</c:v>
+                  <c:v>1566</c:v>
                 </c:pt>
                 <c:pt idx="3">
-                  <c:v>1477</c:v>
+                  <c:v>1832</c:v>
                 </c:pt>
                 <c:pt idx="4">
-                  <c:v>1942</c:v>
+                  <c:v>2383</c:v>
                 </c:pt>
                 <c:pt idx="5">
-                  <c:v>2507</c:v>
+                  <c:v>2948</c:v>
                 </c:pt>
               </c:numCache>
             </c:numRef>
@@ -2272,10 +2272,10 @@
                 <c:formatCode>#,##0</c:formatCode>
                 <c:ptCount val="6"/>
                 <c:pt idx="0">
-                  <c:v>0</c:v>
+                  <c:v>360</c:v>
                 </c:pt>
                 <c:pt idx="1">
-                  <c:v>1250</c:v>
+                  <c:v>0</c:v>
                 </c:pt>
                 <c:pt idx="2">
                   <c:v>180</c:v>
@@ -2442,7 +2442,7 @@
           <p:cNvPr id="6" name="">
             <a:extLst xmlns:a="http://schemas.openxmlformats.org/drawingml/2006/main">
               <a:ext uri="{FF2B5EF4-FFF2-40B4-BE49-F238E27FC236}">
-                <a16:creationId xmlns:a16="http://schemas.microsoft.com/office/drawing/2014/main" id="{FB2420E1-7802-4DB7-AA14-2B9F90B7C409}"/>
+                <a16:creationId xmlns:a16="http://schemas.microsoft.com/office/drawing/2014/main" id="{B20F3A88-81FA-4F55-A521-DD16BD9A1802}"/>
               </a:ext>
             </a:extLst>
           </p:cNvPr>
@@ -2499,7 +2499,7 @@
           <p:cNvPr id="2" name="">
             <a:extLst xmlns:a="http://schemas.openxmlformats.org/drawingml/2006/main">
               <a:ext uri="{FF2B5EF4-FFF2-40B4-BE49-F238E27FC236}">
-                <a16:creationId xmlns:a16="http://schemas.microsoft.com/office/drawing/2014/main" id="{C8E21967-F3D6-43D4-A7C3-97D84B4F7A2E}"/>
+                <a16:creationId xmlns:a16="http://schemas.microsoft.com/office/drawing/2014/main" id="{FFFA2114-35F1-4C31-9EFF-F6A79B44A421}"/>
               </a:ext>
             </a:extLst>
           </p:cNvPr>
@@ -2556,7 +2556,7 @@
           <p:cNvPr id="3" name="">
             <a:extLst xmlns:a="http://schemas.openxmlformats.org/drawingml/2006/main">
               <a:ext uri="{FF2B5EF4-FFF2-40B4-BE49-F238E27FC236}">
-                <a16:creationId xmlns:a16="http://schemas.microsoft.com/office/drawing/2014/main" id="{CB308A38-FBE2-4DE5-92C0-9816372DC536}"/>
+                <a16:creationId xmlns:a16="http://schemas.microsoft.com/office/drawing/2014/main" id="{D0C5134B-E54A-442F-BA32-E4CF22F8ACCF}"/>
               </a:ext>
             </a:extLst>
           </p:cNvPr>
@@ -2613,7 +2613,7 @@
           <p:cNvPr id="4" name="">
             <a:extLst xmlns:a="http://schemas.openxmlformats.org/drawingml/2006/main">
               <a:ext uri="{FF2B5EF4-FFF2-40B4-BE49-F238E27FC236}">
-                <a16:creationId xmlns:a16="http://schemas.microsoft.com/office/drawing/2014/main" id="{F1C13D73-91BC-4714-94C7-7EF2665180AA}"/>
+                <a16:creationId xmlns:a16="http://schemas.microsoft.com/office/drawing/2014/main" id="{7A72A04F-17AC-47A8-8D6F-0DFFE8F431D0}"/>
               </a:ext>
             </a:extLst>
           </p:cNvPr>
@@ -2670,7 +2670,7 @@
           <p:cNvPr id="5" name="">
             <a:extLst xmlns:a="http://schemas.openxmlformats.org/drawingml/2006/main">
               <a:ext uri="{FF2B5EF4-FFF2-40B4-BE49-F238E27FC236}">
-                <a16:creationId xmlns:a16="http://schemas.microsoft.com/office/drawing/2014/main" id="{FAA13465-92A1-4DF5-B393-09B4A8E14488}"/>
+                <a16:creationId xmlns:a16="http://schemas.microsoft.com/office/drawing/2014/main" id="{8E3DD906-1DDF-459D-81E6-E6EE6E5F823E}"/>
               </a:ext>
             </a:extLst>
           </p:cNvPr>
@@ -2681,8 +2681,8 @@
         </p:nvSpPr>
         <p:spPr>
           <a:xfrm xmlns:a="http://schemas.openxmlformats.org/drawingml/2006/main">
-            <a:off x="10858500" y="6381750"/>
-            <a:ext cx="809625" cy="266700"/>
+            <a:off x="10668000" y="6381750"/>
+            <a:ext cx="1000125" cy="266700"/>
           </a:xfrm>
           <a:prstGeom xmlns:a="http://schemas.openxmlformats.org/drawingml/2006/main" prst="rect">
             <a:avLst/>
@@ -2725,7 +2725,7 @@
     </p:spTree>
     <p:extLst>
       <p:ext uri="{BB962C8B-B14F-4D97-AF65-F5344CB8AC3E}">
-        <p14:creationId xmlns:p14="http://schemas.microsoft.com/office/powerpoint/2010/main" val="1349779129"/>
+        <p14:creationId xmlns:p14="http://schemas.microsoft.com/office/powerpoint/2010/main" val="1691133963"/>
       </p:ext>
     </p:extLst>
   </p:cSld>
@@ -2756,7 +2756,7 @@
           <p:cNvPr id="7" name="">
             <a:extLst xmlns:a="http://schemas.openxmlformats.org/drawingml/2006/main">
               <a:ext uri="{FF2B5EF4-FFF2-40B4-BE49-F238E27FC236}">
-                <a16:creationId xmlns:a16="http://schemas.microsoft.com/office/drawing/2014/main" id="{A7C84B0E-861D-430F-B6C7-5939A67440C5}"/>
+                <a16:creationId xmlns:a16="http://schemas.microsoft.com/office/drawing/2014/main" id="{0FF1074E-27AB-4712-9C58-591FCAF5549E}"/>
               </a:ext>
             </a:extLst>
           </p:cNvPr>
@@ -2813,7 +2813,7 @@
           <p:cNvPr id="2" name="">
             <a:extLst xmlns:a="http://schemas.openxmlformats.org/drawingml/2006/main">
               <a:ext uri="{FF2B5EF4-FFF2-40B4-BE49-F238E27FC236}">
-                <a16:creationId xmlns:a16="http://schemas.microsoft.com/office/drawing/2014/main" id="{900338C0-9E6C-4C15-92A3-1853846F6A0D}"/>
+                <a16:creationId xmlns:a16="http://schemas.microsoft.com/office/drawing/2014/main" id="{5792F22F-131C-461D-B834-277CF0ABBE15}"/>
               </a:ext>
             </a:extLst>
           </p:cNvPr>
@@ -2870,7 +2870,7 @@
           <p:cNvPr id="3" name="">
             <a:extLst xmlns:a="http://schemas.openxmlformats.org/drawingml/2006/main">
               <a:ext uri="{FF2B5EF4-FFF2-40B4-BE49-F238E27FC236}">
-                <a16:creationId xmlns:a16="http://schemas.microsoft.com/office/drawing/2014/main" id="{251906A3-B168-4C1B-8403-1C4521C0763F}"/>
+                <a16:creationId xmlns:a16="http://schemas.microsoft.com/office/drawing/2014/main" id="{B067733D-5525-4EDC-B15E-E1ECF4C7D25F}"/>
               </a:ext>
             </a:extLst>
           </p:cNvPr>
@@ -2927,7 +2927,7 @@
           <p:cNvPr id="4" name="">
             <a:extLst xmlns:a="http://schemas.openxmlformats.org/drawingml/2006/main">
               <a:ext uri="{FF2B5EF4-FFF2-40B4-BE49-F238E27FC236}">
-                <a16:creationId xmlns:a16="http://schemas.microsoft.com/office/drawing/2014/main" id="{D4F01562-25C8-45BB-8913-E7874FF2E845}"/>
+                <a16:creationId xmlns:a16="http://schemas.microsoft.com/office/drawing/2014/main" id="{B7A4F2B3-D914-4CD3-947B-739A5CF54AB4}"/>
               </a:ext>
             </a:extLst>
           </p:cNvPr>
@@ -2984,7 +2984,7 @@
           <p:cNvPr id="5" name="">
             <a:extLst xmlns:a="http://schemas.openxmlformats.org/drawingml/2006/main">
               <a:ext uri="{FF2B5EF4-FFF2-40B4-BE49-F238E27FC236}">
-                <a16:creationId xmlns:a16="http://schemas.microsoft.com/office/drawing/2014/main" id="{693EB69D-F173-46C8-A9EB-0D426B9CFF4B}"/>
+                <a16:creationId xmlns:a16="http://schemas.microsoft.com/office/drawing/2014/main" id="{F37801A0-E7BF-4634-A236-BB3B9CF3684C}"/>
               </a:ext>
             </a:extLst>
           </p:cNvPr>
@@ -3041,7 +3041,7 @@
           <p:cNvPr id="6" name="">
             <a:extLst xmlns:a="http://schemas.openxmlformats.org/drawingml/2006/main">
               <a:ext uri="{FF2B5EF4-FFF2-40B4-BE49-F238E27FC236}">
-                <a16:creationId xmlns:a16="http://schemas.microsoft.com/office/drawing/2014/main" id="{2D3D45D4-8DD8-483D-81A2-B33BAEEF6DB6}"/>
+                <a16:creationId xmlns:a16="http://schemas.microsoft.com/office/drawing/2014/main" id="{35E7C1BD-615D-4AAA-990D-A867A9C18413}"/>
               </a:ext>
             </a:extLst>
           </p:cNvPr>
@@ -3052,8 +3052,8 @@
         </p:nvSpPr>
         <p:spPr>
           <a:xfrm xmlns:a="http://schemas.openxmlformats.org/drawingml/2006/main">
-            <a:off x="10858500" y="6381750"/>
-            <a:ext cx="809625" cy="266700"/>
+            <a:off x="10668000" y="6381750"/>
+            <a:ext cx="1000125" cy="266700"/>
           </a:xfrm>
           <a:prstGeom xmlns:a="http://schemas.openxmlformats.org/drawingml/2006/main" prst="rect">
             <a:avLst/>
@@ -3096,7 +3096,7 @@
     </p:spTree>
     <p:extLst>
       <p:ext uri="{BB962C8B-B14F-4D97-AF65-F5344CB8AC3E}">
-        <p14:creationId xmlns:p14="http://schemas.microsoft.com/office/powerpoint/2010/main" val="60625322"/>
+        <p14:creationId xmlns:p14="http://schemas.microsoft.com/office/powerpoint/2010/main" val="265081640"/>
       </p:ext>
     </p:extLst>
   </p:cSld>
@@ -3127,7 +3127,7 @@
           <p:cNvPr id="5" name="">
             <a:extLst xmlns:a="http://schemas.openxmlformats.org/drawingml/2006/main">
               <a:ext uri="{FF2B5EF4-FFF2-40B4-BE49-F238E27FC236}">
-                <a16:creationId xmlns:a16="http://schemas.microsoft.com/office/drawing/2014/main" id="{D2F8DD99-F793-406B-902F-61E00406707D}"/>
+                <a16:creationId xmlns:a16="http://schemas.microsoft.com/office/drawing/2014/main" id="{54A0ECC5-09B6-4725-A1A4-8EBCBE834470}"/>
               </a:ext>
             </a:extLst>
           </p:cNvPr>
@@ -3174,7 +3174,7 @@
                 <a:ea typeface="Arial"/>
                 <a:cs typeface="Arial"/>
               </a:rPr>
-              <a:t>Бюджет P3 по годам</a:t>
+              <a:t>Бюджет P2z по годам</a:t>
             </a:r>
           </a:p>
         </p:txBody>
@@ -3191,7 +3191,7 @@
         </p:xfrm>
         <a:graphic xmlns:a="http://schemas.openxmlformats.org/drawingml/2006/main">
           <a:graphicData uri="http://schemas.openxmlformats.org/drawingml/2006/chart">
-            <c:chart xmlns:r="http://schemas.openxmlformats.org/officeDocument/2006/relationships" xmlns:c="http://schemas.openxmlformats.org/drawingml/2006/chart" r:id="Rc8d82aaa69d64505"/>
+            <c:chart xmlns:r="http://schemas.openxmlformats.org/officeDocument/2006/relationships" xmlns:c="http://schemas.openxmlformats.org/drawingml/2006/chart" r:id="R7ae56c39ed824e6d"/>
           </a:graphicData>
         </a:graphic>
       </p:graphicFrame>
@@ -3200,7 +3200,7 @@
           <p:cNvPr id="3" name="">
             <a:extLst xmlns:a="http://schemas.openxmlformats.org/drawingml/2006/main">
               <a:ext uri="{FF2B5EF4-FFF2-40B4-BE49-F238E27FC236}">
-                <a16:creationId xmlns:a16="http://schemas.microsoft.com/office/drawing/2014/main" id="{C0B456B2-B63B-4D28-A45E-4F53BCE91EDC}"/>
+                <a16:creationId xmlns:a16="http://schemas.microsoft.com/office/drawing/2014/main" id="{04FE4FA7-42B2-43AD-84A7-622E9A86AAB3}"/>
               </a:ext>
             </a:extLst>
           </p:cNvPr>
@@ -3247,7 +3247,7 @@
                 <a:ea typeface="Arial"/>
                 <a:cs typeface="Arial"/>
               </a:rPr>
-              <a:t>ISRU: оплата 2036-01. ZBO: оплата 2037-07. CAPEX P3 до 2037: 1 430 млн.</a:t>
+              <a:t>Earth-New: 360 млн в 2035. ZBO: 180 млн в 2037. CAPEX P2z до 2037: 540 млн.</a:t>
             </a:r>
           </a:p>
         </p:txBody>
@@ -3257,7 +3257,7 @@
           <p:cNvPr id="4" name="">
             <a:extLst xmlns:a="http://schemas.openxmlformats.org/drawingml/2006/main">
               <a:ext uri="{FF2B5EF4-FFF2-40B4-BE49-F238E27FC236}">
-                <a16:creationId xmlns:a16="http://schemas.microsoft.com/office/drawing/2014/main" id="{17BB639C-68C0-4648-A537-8F6800B3093E}"/>
+                <a16:creationId xmlns:a16="http://schemas.microsoft.com/office/drawing/2014/main" id="{A9FE158D-4AD8-470F-AF4C-9BC96F8B0F1E}"/>
               </a:ext>
             </a:extLst>
           </p:cNvPr>
@@ -3268,8 +3268,8 @@
         </p:nvSpPr>
         <p:spPr>
           <a:xfrm xmlns:a="http://schemas.openxmlformats.org/drawingml/2006/main">
-            <a:off x="10858500" y="6381750"/>
-            <a:ext cx="809625" cy="266700"/>
+            <a:off x="10668000" y="6381750"/>
+            <a:ext cx="1000125" cy="266700"/>
           </a:xfrm>
           <a:prstGeom xmlns:a="http://schemas.openxmlformats.org/drawingml/2006/main" prst="rect">
             <a:avLst/>
@@ -3312,7 +3312,7 @@
     </p:spTree>
     <p:extLst>
       <p:ext uri="{BB962C8B-B14F-4D97-AF65-F5344CB8AC3E}">
-        <p14:creationId xmlns:p14="http://schemas.microsoft.com/office/powerpoint/2010/main" val="849464254"/>
+        <p14:creationId xmlns:p14="http://schemas.microsoft.com/office/powerpoint/2010/main" val="177825942"/>
       </p:ext>
     </p:extLst>
   </p:cSld>
@@ -3343,7 +3343,7 @@
           <p:cNvPr id="8" name="">
             <a:extLst xmlns:a="http://schemas.openxmlformats.org/drawingml/2006/main">
               <a:ext uri="{FF2B5EF4-FFF2-40B4-BE49-F238E27FC236}">
-                <a16:creationId xmlns:a16="http://schemas.microsoft.com/office/drawing/2014/main" id="{47B4E163-52E2-4376-9638-78856E5B1C67}"/>
+                <a16:creationId xmlns:a16="http://schemas.microsoft.com/office/drawing/2014/main" id="{A085071B-F863-42CE-A795-70421866399D}"/>
               </a:ext>
             </a:extLst>
           </p:cNvPr>
@@ -3400,7 +3400,7 @@
           <p:cNvPr id="2" name="">
             <a:extLst xmlns:a="http://schemas.openxmlformats.org/drawingml/2006/main">
               <a:ext uri="{FF2B5EF4-FFF2-40B4-BE49-F238E27FC236}">
-                <a16:creationId xmlns:a16="http://schemas.microsoft.com/office/drawing/2014/main" id="{9D9CF54E-9110-4181-9D9B-4F99CAEDA10C}"/>
+                <a16:creationId xmlns:a16="http://schemas.microsoft.com/office/drawing/2014/main" id="{F763A525-55E1-4219-9A75-83E09684C2A1}"/>
               </a:ext>
             </a:extLst>
           </p:cNvPr>
@@ -3457,7 +3457,7 @@
           <p:cNvPr id="3" name="">
             <a:extLst xmlns:a="http://schemas.openxmlformats.org/drawingml/2006/main">
               <a:ext uri="{FF2B5EF4-FFF2-40B4-BE49-F238E27FC236}">
-                <a16:creationId xmlns:a16="http://schemas.microsoft.com/office/drawing/2014/main" id="{0C784DF3-411E-430C-82AA-5348A22A320C}"/>
+                <a16:creationId xmlns:a16="http://schemas.microsoft.com/office/drawing/2014/main" id="{ADD41D96-8C8E-425C-815C-E8E327EA9487}"/>
               </a:ext>
             </a:extLst>
           </p:cNvPr>
@@ -3514,7 +3514,7 @@
           <p:cNvPr id="4" name="">
             <a:extLst xmlns:a="http://schemas.openxmlformats.org/drawingml/2006/main">
               <a:ext uri="{FF2B5EF4-FFF2-40B4-BE49-F238E27FC236}">
-                <a16:creationId xmlns:a16="http://schemas.microsoft.com/office/drawing/2014/main" id="{CBCE5DDF-68FA-4FB3-9A63-E2E14A661A2E}"/>
+                <a16:creationId xmlns:a16="http://schemas.microsoft.com/office/drawing/2014/main" id="{EA4BBEC1-868A-4DF9-9AF2-94F3C658A294}"/>
               </a:ext>
             </a:extLst>
           </p:cNvPr>
@@ -3571,7 +3571,7 @@
           <p:cNvPr id="5" name="">
             <a:extLst xmlns:a="http://schemas.openxmlformats.org/drawingml/2006/main">
               <a:ext uri="{FF2B5EF4-FFF2-40B4-BE49-F238E27FC236}">
-                <a16:creationId xmlns:a16="http://schemas.microsoft.com/office/drawing/2014/main" id="{A078B0F3-C0D1-469C-885C-5B03DED258E4}"/>
+                <a16:creationId xmlns:a16="http://schemas.microsoft.com/office/drawing/2014/main" id="{19411C11-ECC3-42B7-A3EB-D93BC90F894C}"/>
               </a:ext>
             </a:extLst>
           </p:cNvPr>
@@ -3628,7 +3628,7 @@
           <p:cNvPr id="6" name="">
             <a:extLst xmlns:a="http://schemas.openxmlformats.org/drawingml/2006/main">
               <a:ext uri="{FF2B5EF4-FFF2-40B4-BE49-F238E27FC236}">
-                <a16:creationId xmlns:a16="http://schemas.microsoft.com/office/drawing/2014/main" id="{4FC50294-7290-4A3A-838C-A0E0630C9D48}"/>
+                <a16:creationId xmlns:a16="http://schemas.microsoft.com/office/drawing/2014/main" id="{B33D6505-59B7-4C22-918D-C701E4BEA15C}"/>
               </a:ext>
             </a:extLst>
           </p:cNvPr>
@@ -3685,7 +3685,7 @@
           <p:cNvPr id="7" name="">
             <a:extLst xmlns:a="http://schemas.openxmlformats.org/drawingml/2006/main">
               <a:ext uri="{FF2B5EF4-FFF2-40B4-BE49-F238E27FC236}">
-                <a16:creationId xmlns:a16="http://schemas.microsoft.com/office/drawing/2014/main" id="{A2D20ABD-223F-4914-92B7-A9F63DD3A6D6}"/>
+                <a16:creationId xmlns:a16="http://schemas.microsoft.com/office/drawing/2014/main" id="{F46CDF92-F5D4-4585-8858-5114BD901461}"/>
               </a:ext>
             </a:extLst>
           </p:cNvPr>
@@ -3696,8 +3696,8 @@
         </p:nvSpPr>
         <p:spPr>
           <a:xfrm xmlns:a="http://schemas.openxmlformats.org/drawingml/2006/main">
-            <a:off x="10858500" y="6381750"/>
-            <a:ext cx="809625" cy="266700"/>
+            <a:off x="10668000" y="6381750"/>
+            <a:ext cx="1000125" cy="266700"/>
           </a:xfrm>
           <a:prstGeom xmlns:a="http://schemas.openxmlformats.org/drawingml/2006/main" prst="rect">
             <a:avLst/>
@@ -3740,7 +3740,7 @@
     </p:spTree>
     <p:extLst>
       <p:ext uri="{BB962C8B-B14F-4D97-AF65-F5344CB8AC3E}">
-        <p14:creationId xmlns:p14="http://schemas.microsoft.com/office/powerpoint/2010/main" val="416037459"/>
+        <p14:creationId xmlns:p14="http://schemas.microsoft.com/office/powerpoint/2010/main" val="1073811338"/>
       </p:ext>
     </p:extLst>
   </p:cSld>
@@ -3771,7 +3771,7 @@
           <p:cNvPr id="7" name="">
             <a:extLst xmlns:a="http://schemas.openxmlformats.org/drawingml/2006/main">
               <a:ext uri="{FF2B5EF4-FFF2-40B4-BE49-F238E27FC236}">
-                <a16:creationId xmlns:a16="http://schemas.microsoft.com/office/drawing/2014/main" id="{01F24C35-4834-40FF-8972-396853B35F11}"/>
+                <a16:creationId xmlns:a16="http://schemas.microsoft.com/office/drawing/2014/main" id="{B03F92B1-8641-49FC-B24F-704F13C1FC0C}"/>
               </a:ext>
             </a:extLst>
           </p:cNvPr>
@@ -3828,7 +3828,7 @@
           <p:cNvPr id="2" name="">
             <a:extLst xmlns:a="http://schemas.openxmlformats.org/drawingml/2006/main">
               <a:ext uri="{FF2B5EF4-FFF2-40B4-BE49-F238E27FC236}">
-                <a16:creationId xmlns:a16="http://schemas.microsoft.com/office/drawing/2014/main" id="{95D5A675-7425-4767-9DB5-72F238C9020C}"/>
+                <a16:creationId xmlns:a16="http://schemas.microsoft.com/office/drawing/2014/main" id="{87778CC6-8015-478F-8997-84BF8812A46D}"/>
               </a:ext>
             </a:extLst>
           </p:cNvPr>
@@ -3885,7 +3885,7 @@
           <p:cNvPr id="3" name="">
             <a:extLst xmlns:a="http://schemas.openxmlformats.org/drawingml/2006/main">
               <a:ext uri="{FF2B5EF4-FFF2-40B4-BE49-F238E27FC236}">
-                <a16:creationId xmlns:a16="http://schemas.microsoft.com/office/drawing/2014/main" id="{802D75F2-9ECF-4E21-9CE1-C97ABC7C12B8}"/>
+                <a16:creationId xmlns:a16="http://schemas.microsoft.com/office/drawing/2014/main" id="{F4502564-B0CA-47BE-8D9F-5D8AA95333CA}"/>
               </a:ext>
             </a:extLst>
           </p:cNvPr>
@@ -3942,7 +3942,7 @@
           <p:cNvPr id="4" name="">
             <a:extLst xmlns:a="http://schemas.openxmlformats.org/drawingml/2006/main">
               <a:ext uri="{FF2B5EF4-FFF2-40B4-BE49-F238E27FC236}">
-                <a16:creationId xmlns:a16="http://schemas.microsoft.com/office/drawing/2014/main" id="{CD3D19EF-1B8A-45B8-B0CD-8C64D99FB797}"/>
+                <a16:creationId xmlns:a16="http://schemas.microsoft.com/office/drawing/2014/main" id="{12939293-1BEE-409C-A94F-DF797CCB281C}"/>
               </a:ext>
             </a:extLst>
           </p:cNvPr>
@@ -3999,7 +3999,7 @@
           <p:cNvPr id="5" name="">
             <a:extLst xmlns:a="http://schemas.openxmlformats.org/drawingml/2006/main">
               <a:ext uri="{FF2B5EF4-FFF2-40B4-BE49-F238E27FC236}">
-                <a16:creationId xmlns:a16="http://schemas.microsoft.com/office/drawing/2014/main" id="{826E69A1-A199-4213-BD10-FA93DE3DBA29}"/>
+                <a16:creationId xmlns:a16="http://schemas.microsoft.com/office/drawing/2014/main" id="{1B1CC88D-3EAA-4603-85E4-F8A52820EB58}"/>
               </a:ext>
             </a:extLst>
           </p:cNvPr>
@@ -4056,7 +4056,7 @@
           <p:cNvPr id="6" name="">
             <a:extLst xmlns:a="http://schemas.openxmlformats.org/drawingml/2006/main">
               <a:ext uri="{FF2B5EF4-FFF2-40B4-BE49-F238E27FC236}">
-                <a16:creationId xmlns:a16="http://schemas.microsoft.com/office/drawing/2014/main" id="{B305FB6D-FC27-4C88-904F-B58EC338F5DA}"/>
+                <a16:creationId xmlns:a16="http://schemas.microsoft.com/office/drawing/2014/main" id="{B31F13C5-B9A5-434E-A71C-92EEEC7530B5}"/>
               </a:ext>
             </a:extLst>
           </p:cNvPr>
@@ -4067,8 +4067,8 @@
         </p:nvSpPr>
         <p:spPr>
           <a:xfrm xmlns:a="http://schemas.openxmlformats.org/drawingml/2006/main">
-            <a:off x="10858500" y="6381750"/>
-            <a:ext cx="809625" cy="266700"/>
+            <a:off x="10668000" y="6381750"/>
+            <a:ext cx="1000125" cy="266700"/>
           </a:xfrm>
           <a:prstGeom xmlns:a="http://schemas.openxmlformats.org/drawingml/2006/main" prst="rect">
             <a:avLst/>
@@ -4111,7 +4111,7 @@
     </p:spTree>
     <p:extLst>
       <p:ext uri="{BB962C8B-B14F-4D97-AF65-F5344CB8AC3E}">
-        <p14:creationId xmlns:p14="http://schemas.microsoft.com/office/powerpoint/2010/main" val="428898923"/>
+        <p14:creationId xmlns:p14="http://schemas.microsoft.com/office/powerpoint/2010/main" val="1245932137"/>
       </p:ext>
     </p:extLst>
   </p:cSld>
@@ -4142,7 +4142,7 @@
           <p:cNvPr id="7" name="">
             <a:extLst xmlns:a="http://schemas.openxmlformats.org/drawingml/2006/main">
               <a:ext uri="{FF2B5EF4-FFF2-40B4-BE49-F238E27FC236}">
-                <a16:creationId xmlns:a16="http://schemas.microsoft.com/office/drawing/2014/main" id="{49C06481-5549-4917-AEC5-62DFB0CC94EE}"/>
+                <a16:creationId xmlns:a16="http://schemas.microsoft.com/office/drawing/2014/main" id="{E0A419AB-DB4A-4ECC-9690-48BE1E708115}"/>
               </a:ext>
             </a:extLst>
           </p:cNvPr>
@@ -4199,7 +4199,7 @@
           <p:cNvPr id="2" name="">
             <a:extLst xmlns:a="http://schemas.openxmlformats.org/drawingml/2006/main">
               <a:ext uri="{FF2B5EF4-FFF2-40B4-BE49-F238E27FC236}">
-                <a16:creationId xmlns:a16="http://schemas.microsoft.com/office/drawing/2014/main" id="{4E2BCD23-DA75-4528-9F9E-9086CB3B4C2B}"/>
+                <a16:creationId xmlns:a16="http://schemas.microsoft.com/office/drawing/2014/main" id="{CF7071CC-8289-4185-9EF0-114BB1C05F43}"/>
               </a:ext>
             </a:extLst>
           </p:cNvPr>
@@ -4256,7 +4256,7 @@
           <p:cNvPr id="3" name="">
             <a:extLst xmlns:a="http://schemas.openxmlformats.org/drawingml/2006/main">
               <a:ext uri="{FF2B5EF4-FFF2-40B4-BE49-F238E27FC236}">
-                <a16:creationId xmlns:a16="http://schemas.microsoft.com/office/drawing/2014/main" id="{DDE997A7-C68B-4320-BC24-C35F2CBB3E53}"/>
+                <a16:creationId xmlns:a16="http://schemas.microsoft.com/office/drawing/2014/main" id="{496E9CA3-DCF8-4D59-8A08-62CE4FE4D8FC}"/>
               </a:ext>
             </a:extLst>
           </p:cNvPr>
@@ -4313,7 +4313,7 @@
           <p:cNvPr id="4" name="">
             <a:extLst xmlns:a="http://schemas.openxmlformats.org/drawingml/2006/main">
               <a:ext uri="{FF2B5EF4-FFF2-40B4-BE49-F238E27FC236}">
-                <a16:creationId xmlns:a16="http://schemas.microsoft.com/office/drawing/2014/main" id="{598614B2-BAA4-4C0B-8BC0-1EFAC7E268B7}"/>
+                <a16:creationId xmlns:a16="http://schemas.microsoft.com/office/drawing/2014/main" id="{31C8FE46-4B69-4E49-9F2C-3B84A23A31EC}"/>
               </a:ext>
             </a:extLst>
           </p:cNvPr>
@@ -4370,7 +4370,7 @@
           <p:cNvPr id="5" name="">
             <a:extLst xmlns:a="http://schemas.openxmlformats.org/drawingml/2006/main">
               <a:ext uri="{FF2B5EF4-FFF2-40B4-BE49-F238E27FC236}">
-                <a16:creationId xmlns:a16="http://schemas.microsoft.com/office/drawing/2014/main" id="{FB3DBD89-0FF5-4976-B681-7B06352FB75A}"/>
+                <a16:creationId xmlns:a16="http://schemas.microsoft.com/office/drawing/2014/main" id="{9596E4D4-6E31-48B1-B17E-94903F8B84F0}"/>
               </a:ext>
             </a:extLst>
           </p:cNvPr>
@@ -4427,7 +4427,7 @@
           <p:cNvPr id="6" name="">
             <a:extLst xmlns:a="http://schemas.openxmlformats.org/drawingml/2006/main">
               <a:ext uri="{FF2B5EF4-FFF2-40B4-BE49-F238E27FC236}">
-                <a16:creationId xmlns:a16="http://schemas.microsoft.com/office/drawing/2014/main" id="{0817489C-46F4-44C0-B971-66021F444A19}"/>
+                <a16:creationId xmlns:a16="http://schemas.microsoft.com/office/drawing/2014/main" id="{08CA7977-172F-471A-AFA4-CA9026E34FDF}"/>
               </a:ext>
             </a:extLst>
           </p:cNvPr>
@@ -4438,8 +4438,8 @@
         </p:nvSpPr>
         <p:spPr>
           <a:xfrm xmlns:a="http://schemas.openxmlformats.org/drawingml/2006/main">
-            <a:off x="10858500" y="6381750"/>
-            <a:ext cx="809625" cy="266700"/>
+            <a:off x="10668000" y="6381750"/>
+            <a:ext cx="1000125" cy="266700"/>
           </a:xfrm>
           <a:prstGeom xmlns:a="http://schemas.openxmlformats.org/drawingml/2006/main" prst="rect">
             <a:avLst/>
@@ -4482,7 +4482,7 @@
     </p:spTree>
     <p:extLst>
       <p:ext uri="{BB962C8B-B14F-4D97-AF65-F5344CB8AC3E}">
-        <p14:creationId xmlns:p14="http://schemas.microsoft.com/office/powerpoint/2010/main" val="1114842646"/>
+        <p14:creationId xmlns:p14="http://schemas.microsoft.com/office/powerpoint/2010/main" val="326141819"/>
       </p:ext>
     </p:extLst>
   </p:cSld>
@@ -4513,7 +4513,7 @@
           <p:cNvPr id="7" name="">
             <a:extLst xmlns:a="http://schemas.openxmlformats.org/drawingml/2006/main">
               <a:ext uri="{FF2B5EF4-FFF2-40B4-BE49-F238E27FC236}">
-                <a16:creationId xmlns:a16="http://schemas.microsoft.com/office/drawing/2014/main" id="{A511F395-2695-418E-9CD5-196D9108F6E7}"/>
+                <a16:creationId xmlns:a16="http://schemas.microsoft.com/office/drawing/2014/main" id="{C401FB27-B975-4CA8-B637-2787B5B0AEB3}"/>
               </a:ext>
             </a:extLst>
           </p:cNvPr>
@@ -4570,7 +4570,7 @@
           <p:cNvPr id="2" name="">
             <a:extLst xmlns:a="http://schemas.openxmlformats.org/drawingml/2006/main">
               <a:ext uri="{FF2B5EF4-FFF2-40B4-BE49-F238E27FC236}">
-                <a16:creationId xmlns:a16="http://schemas.microsoft.com/office/drawing/2014/main" id="{F45E03FB-FB7E-4624-9C9C-04AE91F11C82}"/>
+                <a16:creationId xmlns:a16="http://schemas.microsoft.com/office/drawing/2014/main" id="{5D731B25-A56B-4185-9AE3-D71D0096CECD}"/>
               </a:ext>
             </a:extLst>
           </p:cNvPr>
@@ -4627,7 +4627,7 @@
           <p:cNvPr id="3" name="">
             <a:extLst xmlns:a="http://schemas.openxmlformats.org/drawingml/2006/main">
               <a:ext uri="{FF2B5EF4-FFF2-40B4-BE49-F238E27FC236}">
-                <a16:creationId xmlns:a16="http://schemas.microsoft.com/office/drawing/2014/main" id="{EF2A2FA9-1866-48A7-8A23-F689E7A43EE9}"/>
+                <a16:creationId xmlns:a16="http://schemas.microsoft.com/office/drawing/2014/main" id="{7A76BAD7-2A7F-4833-B92D-B08C253F9EB2}"/>
               </a:ext>
             </a:extLst>
           </p:cNvPr>
@@ -4684,7 +4684,7 @@
           <p:cNvPr id="4" name="">
             <a:extLst xmlns:a="http://schemas.openxmlformats.org/drawingml/2006/main">
               <a:ext uri="{FF2B5EF4-FFF2-40B4-BE49-F238E27FC236}">
-                <a16:creationId xmlns:a16="http://schemas.microsoft.com/office/drawing/2014/main" id="{BA652C1C-6876-4692-964F-889D84804BA6}"/>
+                <a16:creationId xmlns:a16="http://schemas.microsoft.com/office/drawing/2014/main" id="{3B2AC29B-B980-4603-9C6B-9BB762EAEAF8}"/>
               </a:ext>
             </a:extLst>
           </p:cNvPr>
@@ -4741,7 +4741,7 @@
           <p:cNvPr id="5" name="">
             <a:extLst xmlns:a="http://schemas.openxmlformats.org/drawingml/2006/main">
               <a:ext uri="{FF2B5EF4-FFF2-40B4-BE49-F238E27FC236}">
-                <a16:creationId xmlns:a16="http://schemas.microsoft.com/office/drawing/2014/main" id="{C3ED864F-1004-4C8A-B002-9D1057D9953B}"/>
+                <a16:creationId xmlns:a16="http://schemas.microsoft.com/office/drawing/2014/main" id="{ABEC591E-C2A5-4A10-8628-812A4BD0B82F}"/>
               </a:ext>
             </a:extLst>
           </p:cNvPr>
@@ -4798,7 +4798,7 @@
           <p:cNvPr id="6" name="">
             <a:extLst xmlns:a="http://schemas.openxmlformats.org/drawingml/2006/main">
               <a:ext uri="{FF2B5EF4-FFF2-40B4-BE49-F238E27FC236}">
-                <a16:creationId xmlns:a16="http://schemas.microsoft.com/office/drawing/2014/main" id="{D2E7B30A-BA7C-4E7B-ACAB-735A4677256D}"/>
+                <a16:creationId xmlns:a16="http://schemas.microsoft.com/office/drawing/2014/main" id="{D74D77C7-A907-45C4-97FC-7B02A2A975D0}"/>
               </a:ext>
             </a:extLst>
           </p:cNvPr>
@@ -4809,8 +4809,8 @@
         </p:nvSpPr>
         <p:spPr>
           <a:xfrm xmlns:a="http://schemas.openxmlformats.org/drawingml/2006/main">
-            <a:off x="10858500" y="6381750"/>
-            <a:ext cx="809625" cy="266700"/>
+            <a:off x="10668000" y="6381750"/>
+            <a:ext cx="1000125" cy="266700"/>
           </a:xfrm>
           <a:prstGeom xmlns:a="http://schemas.openxmlformats.org/drawingml/2006/main" prst="rect">
             <a:avLst/>
@@ -4853,7 +4853,7 @@
     </p:spTree>
     <p:extLst>
       <p:ext uri="{BB962C8B-B14F-4D97-AF65-F5344CB8AC3E}">
-        <p14:creationId xmlns:p14="http://schemas.microsoft.com/office/powerpoint/2010/main" val="340988831"/>
+        <p14:creationId xmlns:p14="http://schemas.microsoft.com/office/powerpoint/2010/main" val="586961655"/>
       </p:ext>
     </p:extLst>
   </p:cSld>
@@ -4884,7 +4884,7 @@
           <p:cNvPr id="5" name="">
             <a:extLst xmlns:a="http://schemas.openxmlformats.org/drawingml/2006/main">
               <a:ext uri="{FF2B5EF4-FFF2-40B4-BE49-F238E27FC236}">
-                <a16:creationId xmlns:a16="http://schemas.microsoft.com/office/drawing/2014/main" id="{C4485657-3B0E-4FFB-81EB-B045AA7D48C4}"/>
+                <a16:creationId xmlns:a16="http://schemas.microsoft.com/office/drawing/2014/main" id="{E863C370-D25A-49E8-BB86-9ABA724735A9}"/>
               </a:ext>
             </a:extLst>
           </p:cNvPr>
@@ -4931,7 +4931,7 @@
                 <a:ea typeface="Arial"/>
                 <a:cs typeface="Arial"/>
               </a:rPr>
-              <a:t>Сравнение исполнимых планов в BASE</a:t>
+              <a:t>P2z выбран после жёсткого фильтра</a:t>
             </a:r>
           </a:p>
         </p:txBody>
@@ -4948,7 +4948,7 @@
         </p:xfrm>
         <a:graphic xmlns:a="http://schemas.openxmlformats.org/drawingml/2006/main">
           <a:graphicData uri="http://schemas.openxmlformats.org/drawingml/2006/chart">
-            <c:chart xmlns:r="http://schemas.openxmlformats.org/officeDocument/2006/relationships" xmlns:c="http://schemas.openxmlformats.org/drawingml/2006/chart" r:id="Rb04831d5001f4741"/>
+            <c:chart xmlns:r="http://schemas.openxmlformats.org/officeDocument/2006/relationships" xmlns:c="http://schemas.openxmlformats.org/drawingml/2006/chart" r:id="R6efeba33dc714f11"/>
           </a:graphicData>
         </a:graphic>
       </p:graphicFrame>
@@ -4957,7 +4957,7 @@
           <p:cNvPr id="3" name="">
             <a:extLst xmlns:a="http://schemas.openxmlformats.org/drawingml/2006/main">
               <a:ext uri="{FF2B5EF4-FFF2-40B4-BE49-F238E27FC236}">
-                <a16:creationId xmlns:a16="http://schemas.microsoft.com/office/drawing/2014/main" id="{FF32DC05-4126-48CD-A802-17FF1850EC6D}"/>
+                <a16:creationId xmlns:a16="http://schemas.microsoft.com/office/drawing/2014/main" id="{554AF383-8293-4B8C-B15D-81EFF849B995}"/>
               </a:ext>
             </a:extLst>
           </p:cNvPr>
@@ -5004,7 +5004,7 @@
                 <a:ea typeface="Arial"/>
                 <a:cs typeface="Arial"/>
               </a:rPr>
-              <a:t>P1 не проходит ограничения и исключён из ценового ранжирования.</a:t>
+              <a:t>P2z не самый дешёвый в BASE, но выигрывает все раскрытые профили MCDA за счёт CAPEX и стоимости адаптации.</a:t>
             </a:r>
           </a:p>
         </p:txBody>
@@ -5014,7 +5014,7 @@
           <p:cNvPr id="4" name="">
             <a:extLst xmlns:a="http://schemas.openxmlformats.org/drawingml/2006/main">
               <a:ext uri="{FF2B5EF4-FFF2-40B4-BE49-F238E27FC236}">
-                <a16:creationId xmlns:a16="http://schemas.microsoft.com/office/drawing/2014/main" id="{7EC29A5E-952E-454C-9C68-C5BB32AC09BD}"/>
+                <a16:creationId xmlns:a16="http://schemas.microsoft.com/office/drawing/2014/main" id="{621C9F55-885A-473A-A64B-83B7924116E2}"/>
               </a:ext>
             </a:extLst>
           </p:cNvPr>
@@ -5025,8 +5025,8 @@
         </p:nvSpPr>
         <p:spPr>
           <a:xfrm xmlns:a="http://schemas.openxmlformats.org/drawingml/2006/main">
-            <a:off x="10858500" y="6381750"/>
-            <a:ext cx="809625" cy="266700"/>
+            <a:off x="10668000" y="6381750"/>
+            <a:ext cx="1000125" cy="266700"/>
           </a:xfrm>
           <a:prstGeom xmlns:a="http://schemas.openxmlformats.org/drawingml/2006/main" prst="rect">
             <a:avLst/>
@@ -5069,7 +5069,7 @@
     </p:spTree>
     <p:extLst>
       <p:ext uri="{BB962C8B-B14F-4D97-AF65-F5344CB8AC3E}">
-        <p14:creationId xmlns:p14="http://schemas.microsoft.com/office/powerpoint/2010/main" val="327769995"/>
+        <p14:creationId xmlns:p14="http://schemas.microsoft.com/office/powerpoint/2010/main" val="1897428608"/>
       </p:ext>
     </p:extLst>
   </p:cSld>
@@ -5100,7 +5100,7 @@
           <p:cNvPr id="7" name="">
             <a:extLst xmlns:a="http://schemas.openxmlformats.org/drawingml/2006/main">
               <a:ext uri="{FF2B5EF4-FFF2-40B4-BE49-F238E27FC236}">
-                <a16:creationId xmlns:a16="http://schemas.microsoft.com/office/drawing/2014/main" id="{47952DF4-2D64-4269-AC85-B63CD4DA7190}"/>
+                <a16:creationId xmlns:a16="http://schemas.microsoft.com/office/drawing/2014/main" id="{78C91BCE-1C40-4288-8A4B-E32757369859}"/>
               </a:ext>
             </a:extLst>
           </p:cNvPr>
@@ -5147,7 +5147,7 @@
                 <a:ea typeface="Arial"/>
                 <a:cs typeface="Arial"/>
               </a:rPr>
-              <a:t>P3 в обязательном стрессе</a:t>
+              <a:t>Обязательный стресс P2z</a:t>
             </a:r>
           </a:p>
         </p:txBody>
@@ -5157,7 +5157,7 @@
           <p:cNvPr id="2" name="">
             <a:extLst xmlns:a="http://schemas.openxmlformats.org/drawingml/2006/main">
               <a:ext uri="{FF2B5EF4-FFF2-40B4-BE49-F238E27FC236}">
-                <a16:creationId xmlns:a16="http://schemas.microsoft.com/office/drawing/2014/main" id="{26E89F25-6F31-48B3-992D-0ABA329FF249}"/>
+                <a16:creationId xmlns:a16="http://schemas.microsoft.com/office/drawing/2014/main" id="{27AF21CA-9BC2-4D8D-87E0-8F4506433549}"/>
               </a:ext>
             </a:extLst>
           </p:cNvPr>
@@ -5204,7 +5204,7 @@
                 <a:ea typeface="Arial"/>
                 <a:cs typeface="Arial"/>
               </a:rPr>
-              <a:t>Неизменный план: дефицит 170.0 т.</a:t>
+              <a:t>Неизменный план: дефицит 95.9 т.</a:t>
             </a:r>
           </a:p>
         </p:txBody>
@@ -5214,7 +5214,7 @@
           <p:cNvPr id="3" name="">
             <a:extLst xmlns:a="http://schemas.openxmlformats.org/drawingml/2006/main">
               <a:ext uri="{FF2B5EF4-FFF2-40B4-BE49-F238E27FC236}">
-                <a16:creationId xmlns:a16="http://schemas.microsoft.com/office/drawing/2014/main" id="{CCE7BD6B-F13B-4561-A05D-D76EAF5C8AA1}"/>
+                <a16:creationId xmlns:a16="http://schemas.microsoft.com/office/drawing/2014/main" id="{BB4E8116-31B2-4037-82E7-F7DB071168BF}"/>
               </a:ext>
             </a:extLst>
           </p:cNvPr>
@@ -5271,7 +5271,7 @@
           <p:cNvPr id="4" name="">
             <a:extLst xmlns:a="http://schemas.openxmlformats.org/drawingml/2006/main">
               <a:ext uri="{FF2B5EF4-FFF2-40B4-BE49-F238E27FC236}">
-                <a16:creationId xmlns:a16="http://schemas.microsoft.com/office/drawing/2014/main" id="{5B195307-660C-44B2-84F9-F38EE6C04941}"/>
+                <a16:creationId xmlns:a16="http://schemas.microsoft.com/office/drawing/2014/main" id="{0D078D73-7FCB-47E2-96B4-EA6E9DE93021}"/>
               </a:ext>
             </a:extLst>
           </p:cNvPr>
@@ -5328,7 +5328,7 @@
           <p:cNvPr id="5" name="">
             <a:extLst xmlns:a="http://schemas.openxmlformats.org/drawingml/2006/main">
               <a:ext uri="{FF2B5EF4-FFF2-40B4-BE49-F238E27FC236}">
-                <a16:creationId xmlns:a16="http://schemas.microsoft.com/office/drawing/2014/main" id="{60C4B635-FFBA-489F-A365-2F78A60B7CFC}"/>
+                <a16:creationId xmlns:a16="http://schemas.microsoft.com/office/drawing/2014/main" id="{E3E39D7B-5803-4BD4-B517-6A8092C4B0FB}"/>
               </a:ext>
             </a:extLst>
           </p:cNvPr>
@@ -5375,7 +5375,7 @@
                 <a:ea typeface="Arial"/>
                 <a:cs typeface="Arial"/>
               </a:rPr>
-              <a:t>Поставка ISRU: 55 % в 2038 и 75 % в 2039, без повторного множителя надёжности.</a:t>
+              <a:t>P2z не использует ISRU: его проблема в стрессе — недостаточный график заказов и запас.</a:t>
             </a:r>
           </a:p>
         </p:txBody>
@@ -5385,7 +5385,7 @@
           <p:cNvPr id="6" name="">
             <a:extLst xmlns:a="http://schemas.openxmlformats.org/drawingml/2006/main">
               <a:ext uri="{FF2B5EF4-FFF2-40B4-BE49-F238E27FC236}">
-                <a16:creationId xmlns:a16="http://schemas.microsoft.com/office/drawing/2014/main" id="{E1953F76-04F2-43AA-A199-9C1B7B904DE1}"/>
+                <a16:creationId xmlns:a16="http://schemas.microsoft.com/office/drawing/2014/main" id="{359FD71E-A4B3-4E10-A95E-FA1319DE033C}"/>
               </a:ext>
             </a:extLst>
           </p:cNvPr>
@@ -5396,8 +5396,8 @@
         </p:nvSpPr>
         <p:spPr>
           <a:xfrm xmlns:a="http://schemas.openxmlformats.org/drawingml/2006/main">
-            <a:off x="10858500" y="6381750"/>
-            <a:ext cx="809625" cy="266700"/>
+            <a:off x="10668000" y="6381750"/>
+            <a:ext cx="1000125" cy="266700"/>
           </a:xfrm>
           <a:prstGeom xmlns:a="http://schemas.openxmlformats.org/drawingml/2006/main" prst="rect">
             <a:avLst/>
@@ -5440,7 +5440,7 @@
     </p:spTree>
     <p:extLst>
       <p:ext uri="{BB962C8B-B14F-4D97-AF65-F5344CB8AC3E}">
-        <p14:creationId xmlns:p14="http://schemas.microsoft.com/office/powerpoint/2010/main" val="895809637"/>
+        <p14:creationId xmlns:p14="http://schemas.microsoft.com/office/powerpoint/2010/main" val="885476813"/>
       </p:ext>
     </p:extLst>
   </p:cSld>
@@ -5471,7 +5471,7 @@
           <p:cNvPr id="5" name="">
             <a:extLst xmlns:a="http://schemas.openxmlformats.org/drawingml/2006/main">
               <a:ext uri="{FF2B5EF4-FFF2-40B4-BE49-F238E27FC236}">
-                <a16:creationId xmlns:a16="http://schemas.microsoft.com/office/drawing/2014/main" id="{C73F8B7D-DC8E-42CF-99FA-54E0A8811E5F}"/>
+                <a16:creationId xmlns:a16="http://schemas.microsoft.com/office/drawing/2014/main" id="{A05EA3E1-37D1-4389-948D-0A8F44EB87C8}"/>
               </a:ext>
             </a:extLst>
           </p:cNvPr>
@@ -5518,7 +5518,7 @@
                 <a:ea typeface="Arial"/>
                 <a:cs typeface="Arial"/>
               </a:rPr>
-              <a:t>Заблаговременная адаптация P3</a:t>
+              <a:t>Заблаговременная адаптация P2z</a:t>
             </a:r>
           </a:p>
         </p:txBody>
@@ -5535,7 +5535,7 @@
         </p:xfrm>
         <a:graphic xmlns:a="http://schemas.openxmlformats.org/drawingml/2006/main">
           <a:graphicData uri="http://schemas.openxmlformats.org/drawingml/2006/chart">
-            <c:chart xmlns:r="http://schemas.openxmlformats.org/officeDocument/2006/relationships" xmlns:c="http://schemas.openxmlformats.org/drawingml/2006/chart" r:id="Rd3a6c5b17a734422"/>
+            <c:chart xmlns:r="http://schemas.openxmlformats.org/officeDocument/2006/relationships" xmlns:c="http://schemas.openxmlformats.org/drawingml/2006/chart" r:id="R7c4a813e1ecd4416"/>
           </a:graphicData>
         </a:graphic>
       </p:graphicFrame>
@@ -5544,7 +5544,7 @@
           <p:cNvPr id="3" name="">
             <a:extLst xmlns:a="http://schemas.openxmlformats.org/drawingml/2006/main">
               <a:ext uri="{FF2B5EF4-FFF2-40B4-BE49-F238E27FC236}">
-                <a16:creationId xmlns:a16="http://schemas.microsoft.com/office/drawing/2014/main" id="{5466D784-6928-471E-A001-E732F4B217A1}"/>
+                <a16:creationId xmlns:a16="http://schemas.microsoft.com/office/drawing/2014/main" id="{92C18306-DA70-4B2A-836A-F37C75B7265C}"/>
               </a:ext>
             </a:extLst>
           </p:cNvPr>
@@ -5591,7 +5591,7 @@
                 <a:ea typeface="Arial"/>
                 <a:cs typeface="Arial"/>
               </a:rPr>
-              <a:t>Адаптация: дефицит 0 т, жёстких нарушений 0. Это разные решения, не гарантия робастности.</a:t>
+              <a:t>Адаптация: дефицит 0 т, жёстких нарушений 0. График зависит от сценария: адаптированный план переполняет хранилище в BASE.</a:t>
             </a:r>
           </a:p>
         </p:txBody>
@@ -5601,7 +5601,7 @@
           <p:cNvPr id="4" name="">
             <a:extLst xmlns:a="http://schemas.openxmlformats.org/drawingml/2006/main">
               <a:ext uri="{FF2B5EF4-FFF2-40B4-BE49-F238E27FC236}">
-                <a16:creationId xmlns:a16="http://schemas.microsoft.com/office/drawing/2014/main" id="{67C39BAF-C5CC-4A85-A116-F079E593E612}"/>
+                <a16:creationId xmlns:a16="http://schemas.microsoft.com/office/drawing/2014/main" id="{785B7E7E-FDE2-4918-82CB-603DD8D9A8BF}"/>
               </a:ext>
             </a:extLst>
           </p:cNvPr>
@@ -5612,8 +5612,8 @@
         </p:nvSpPr>
         <p:spPr>
           <a:xfrm xmlns:a="http://schemas.openxmlformats.org/drawingml/2006/main">
-            <a:off x="10858500" y="6381750"/>
-            <a:ext cx="809625" cy="266700"/>
+            <a:off x="10668000" y="6381750"/>
+            <a:ext cx="1000125" cy="266700"/>
           </a:xfrm>
           <a:prstGeom xmlns:a="http://schemas.openxmlformats.org/drawingml/2006/main" prst="rect">
             <a:avLst/>
@@ -5656,7 +5656,7 @@
     </p:spTree>
     <p:extLst>
       <p:ext uri="{BB962C8B-B14F-4D97-AF65-F5344CB8AC3E}">
-        <p14:creationId xmlns:p14="http://schemas.microsoft.com/office/powerpoint/2010/main" val="415119484"/>
+        <p14:creationId xmlns:p14="http://schemas.microsoft.com/office/powerpoint/2010/main" val="1058857205"/>
       </p:ext>
     </p:extLst>
   </p:cSld>
@@ -5687,7 +5687,7 @@
           <p:cNvPr id="7" name="">
             <a:extLst xmlns:a="http://schemas.openxmlformats.org/drawingml/2006/main">
               <a:ext uri="{FF2B5EF4-FFF2-40B4-BE49-F238E27FC236}">
-                <a16:creationId xmlns:a16="http://schemas.microsoft.com/office/drawing/2014/main" id="{E9C19A69-415D-4D7E-BC8A-B926C31A1486}"/>
+                <a16:creationId xmlns:a16="http://schemas.microsoft.com/office/drawing/2014/main" id="{8C500D5E-7764-4B13-8BCA-5B04D678416F}"/>
               </a:ext>
             </a:extLst>
           </p:cNvPr>
@@ -5734,7 +5734,7 @@
                 <a:ea typeface="Arial"/>
                 <a:cs typeface="Arial"/>
               </a:rPr>
-              <a:t>Риски и правила реакции</a:t>
+              <a:t>Риски выбранной стратегии</a:t>
             </a:r>
           </a:p>
         </p:txBody>
@@ -5744,7 +5744,7 @@
           <p:cNvPr id="2" name="">
             <a:extLst xmlns:a="http://schemas.openxmlformats.org/drawingml/2006/main">
               <a:ext uri="{FF2B5EF4-FFF2-40B4-BE49-F238E27FC236}">
-                <a16:creationId xmlns:a16="http://schemas.microsoft.com/office/drawing/2014/main" id="{D3F65564-0244-42CF-ACD9-7CB92B76493D}"/>
+                <a16:creationId xmlns:a16="http://schemas.microsoft.com/office/drawing/2014/main" id="{1E0982C9-7EF5-4EA6-B20B-290FDF440A1D}"/>
               </a:ext>
             </a:extLst>
           </p:cNvPr>
@@ -5801,7 +5801,7 @@
           <p:cNvPr id="3" name="">
             <a:extLst xmlns:a="http://schemas.openxmlformats.org/drawingml/2006/main">
               <a:ext uri="{FF2B5EF4-FFF2-40B4-BE49-F238E27FC236}">
-                <a16:creationId xmlns:a16="http://schemas.microsoft.com/office/drawing/2014/main" id="{94271407-D4E1-4751-AC4B-FDC6F62FE6E2}"/>
+                <a16:creationId xmlns:a16="http://schemas.microsoft.com/office/drawing/2014/main" id="{796132ED-7DE0-4CCC-8C02-59CE91D1C72A}"/>
               </a:ext>
             </a:extLst>
           </p:cNvPr>
@@ -5848,7 +5848,7 @@
                 <a:ea typeface="Arial"/>
                 <a:cs typeface="Arial"/>
               </a:rPr>
-              <a:t>Дозаказ Flex требует 4 месяцев, Emergency — 6 недель.</a:t>
+              <a:t>EXP-09: задержка Earth-New уже на 3 месяца нарушает резерв P2z в 2038–2040.</a:t>
             </a:r>
           </a:p>
         </p:txBody>
@@ -5858,7 +5858,7 @@
           <p:cNvPr id="4" name="">
             <a:extLst xmlns:a="http://schemas.openxmlformats.org/drawingml/2006/main">
               <a:ext uri="{FF2B5EF4-FFF2-40B4-BE49-F238E27FC236}">
-                <a16:creationId xmlns:a16="http://schemas.microsoft.com/office/drawing/2014/main" id="{E3C3C014-8163-421B-B558-9F539BF41385}"/>
+                <a16:creationId xmlns:a16="http://schemas.microsoft.com/office/drawing/2014/main" id="{B0102745-70EB-49A4-BE35-5FD47E8065EC}"/>
               </a:ext>
             </a:extLst>
           </p:cNvPr>
@@ -5905,7 +5905,7 @@
                 <a:ea typeface="Arial"/>
                 <a:cs typeface="Arial"/>
               </a:rPr>
-              <a:t>EXP-07–10: обратный стресс, меры защиты, задержка Earth-New и Монте-Карло.</a:t>
+              <a:t>EXP-11: ценовой шок A/B +25 % добавляет P2z 470,9 млн PV без физического дефицита.</a:t>
             </a:r>
           </a:p>
         </p:txBody>
@@ -5915,7 +5915,7 @@
           <p:cNvPr id="5" name="">
             <a:extLst xmlns:a="http://schemas.openxmlformats.org/drawingml/2006/main">
               <a:ext uri="{FF2B5EF4-FFF2-40B4-BE49-F238E27FC236}">
-                <a16:creationId xmlns:a16="http://schemas.microsoft.com/office/drawing/2014/main" id="{5451891A-0A15-4787-A412-CA879D76CFE7}"/>
+                <a16:creationId xmlns:a16="http://schemas.microsoft.com/office/drawing/2014/main" id="{204D4DDD-EF96-41BE-AA61-4F0D0F2A8D74}"/>
               </a:ext>
             </a:extLst>
           </p:cNvPr>
@@ -5962,7 +5962,7 @@
                 <a:ea typeface="Arial"/>
                 <a:cs typeface="Arial"/>
               </a:rPr>
-              <a:t>Монте-Карло: N = 10 000, seed = 203510. Распределения TEAM_ASSUMPTION, вероятности не калиброваны.</a:t>
+              <a:t>EXP-07–10 исследуют P3. Их частоты нельзя переносить на P2z без нового расчёта.</a:t>
             </a:r>
           </a:p>
         </p:txBody>
@@ -5972,7 +5972,7 @@
           <p:cNvPr id="6" name="">
             <a:extLst xmlns:a="http://schemas.openxmlformats.org/drawingml/2006/main">
               <a:ext uri="{FF2B5EF4-FFF2-40B4-BE49-F238E27FC236}">
-                <a16:creationId xmlns:a16="http://schemas.microsoft.com/office/drawing/2014/main" id="{E1195AB7-1BE0-47BB-91BC-CF17BFEE3849}"/>
+                <a16:creationId xmlns:a16="http://schemas.microsoft.com/office/drawing/2014/main" id="{A8659AA1-0E01-42DB-A7CE-0FF30335E9F4}"/>
               </a:ext>
             </a:extLst>
           </p:cNvPr>
@@ -5983,8 +5983,8 @@
         </p:nvSpPr>
         <p:spPr>
           <a:xfrm xmlns:a="http://schemas.openxmlformats.org/drawingml/2006/main">
-            <a:off x="10858500" y="6381750"/>
-            <a:ext cx="809625" cy="266700"/>
+            <a:off x="10668000" y="6381750"/>
+            <a:ext cx="1000125" cy="266700"/>
           </a:xfrm>
           <a:prstGeom xmlns:a="http://schemas.openxmlformats.org/drawingml/2006/main" prst="rect">
             <a:avLst/>
@@ -6027,7 +6027,7 @@
     </p:spTree>
     <p:extLst>
       <p:ext uri="{BB962C8B-B14F-4D97-AF65-F5344CB8AC3E}">
-        <p14:creationId xmlns:p14="http://schemas.microsoft.com/office/powerpoint/2010/main" val="944723498"/>
+        <p14:creationId xmlns:p14="http://schemas.microsoft.com/office/powerpoint/2010/main" val="1432132540"/>
       </p:ext>
     </p:extLst>
   </p:cSld>
@@ -6058,7 +6058,7 @@
           <p:cNvPr id="7" name="">
             <a:extLst xmlns:a="http://schemas.openxmlformats.org/drawingml/2006/main">
               <a:ext uri="{FF2B5EF4-FFF2-40B4-BE49-F238E27FC236}">
-                <a16:creationId xmlns:a16="http://schemas.microsoft.com/office/drawing/2014/main" id="{C6AAE3CA-32BC-4D36-8AA7-76E5B543E9A9}"/>
+                <a16:creationId xmlns:a16="http://schemas.microsoft.com/office/drawing/2014/main" id="{1EAC2048-AFAC-42F4-AE86-E896D47F07E6}"/>
               </a:ext>
             </a:extLst>
           </p:cNvPr>
@@ -6115,7 +6115,7 @@
           <p:cNvPr id="2" name="">
             <a:extLst xmlns:a="http://schemas.openxmlformats.org/drawingml/2006/main">
               <a:ext uri="{FF2B5EF4-FFF2-40B4-BE49-F238E27FC236}">
-                <a16:creationId xmlns:a16="http://schemas.microsoft.com/office/drawing/2014/main" id="{F04C2462-D70B-4223-87B5-3C2B47345170}"/>
+                <a16:creationId xmlns:a16="http://schemas.microsoft.com/office/drawing/2014/main" id="{84C91927-4FEF-4DE3-9111-D0203F445461}"/>
               </a:ext>
             </a:extLst>
           </p:cNvPr>
@@ -6172,7 +6172,7 @@
           <p:cNvPr id="3" name="">
             <a:extLst xmlns:a="http://schemas.openxmlformats.org/drawingml/2006/main">
               <a:ext uri="{FF2B5EF4-FFF2-40B4-BE49-F238E27FC236}">
-                <a16:creationId xmlns:a16="http://schemas.microsoft.com/office/drawing/2014/main" id="{5CDD37DF-D081-443C-B512-CDBE9EDADBD1}"/>
+                <a16:creationId xmlns:a16="http://schemas.microsoft.com/office/drawing/2014/main" id="{98730F57-79FB-434E-B5AC-E6285A2FEFB8}"/>
               </a:ext>
             </a:extLst>
           </p:cNvPr>
@@ -6229,7 +6229,7 @@
           <p:cNvPr id="4" name="">
             <a:extLst xmlns:a="http://schemas.openxmlformats.org/drawingml/2006/main">
               <a:ext uri="{FF2B5EF4-FFF2-40B4-BE49-F238E27FC236}">
-                <a16:creationId xmlns:a16="http://schemas.microsoft.com/office/drawing/2014/main" id="{448D663C-7DC5-4C35-B481-B546DF52C518}"/>
+                <a16:creationId xmlns:a16="http://schemas.microsoft.com/office/drawing/2014/main" id="{67EDE375-53EF-495B-ADBC-91350A3F2034}"/>
               </a:ext>
             </a:extLst>
           </p:cNvPr>
@@ -6286,7 +6286,7 @@
           <p:cNvPr id="5" name="">
             <a:extLst xmlns:a="http://schemas.openxmlformats.org/drawingml/2006/main">
               <a:ext uri="{FF2B5EF4-FFF2-40B4-BE49-F238E27FC236}">
-                <a16:creationId xmlns:a16="http://schemas.microsoft.com/office/drawing/2014/main" id="{BF10EA79-DDFC-4572-9228-8394BDFC79EF}"/>
+                <a16:creationId xmlns:a16="http://schemas.microsoft.com/office/drawing/2014/main" id="{112186D6-6D9B-47CC-B307-0CD7FD59B759}"/>
               </a:ext>
             </a:extLst>
           </p:cNvPr>
@@ -6343,7 +6343,7 @@
           <p:cNvPr id="6" name="">
             <a:extLst xmlns:a="http://schemas.openxmlformats.org/drawingml/2006/main">
               <a:ext uri="{FF2B5EF4-FFF2-40B4-BE49-F238E27FC236}">
-                <a16:creationId xmlns:a16="http://schemas.microsoft.com/office/drawing/2014/main" id="{7BD4E147-E151-4D54-A76A-41A5A6391BB3}"/>
+                <a16:creationId xmlns:a16="http://schemas.microsoft.com/office/drawing/2014/main" id="{FD050DE3-9FC2-4090-B865-3E47B6312542}"/>
               </a:ext>
             </a:extLst>
           </p:cNvPr>
@@ -6354,8 +6354,8 @@
         </p:nvSpPr>
         <p:spPr>
           <a:xfrm xmlns:a="http://schemas.openxmlformats.org/drawingml/2006/main">
-            <a:off x="10858500" y="6381750"/>
-            <a:ext cx="809625" cy="266700"/>
+            <a:off x="10668000" y="6381750"/>
+            <a:ext cx="1000125" cy="266700"/>
           </a:xfrm>
           <a:prstGeom xmlns:a="http://schemas.openxmlformats.org/drawingml/2006/main" prst="rect">
             <a:avLst/>
@@ -6398,7 +6398,7 @@
     </p:spTree>
     <p:extLst>
       <p:ext uri="{BB962C8B-B14F-4D97-AF65-F5344CB8AC3E}">
-        <p14:creationId xmlns:p14="http://schemas.microsoft.com/office/powerpoint/2010/main" val="1855393947"/>
+        <p14:creationId xmlns:p14="http://schemas.microsoft.com/office/powerpoint/2010/main" val="1310279752"/>
       </p:ext>
     </p:extLst>
   </p:cSld>

</xml_diff>